<commit_message>
Add slide on TECHi
</commit_message>
<xml_diff>
--- a/lectures/00-introduction.pptx
+++ b/lectures/00-introduction.pptx
@@ -17,6 +17,7 @@
     <p:sldId id="265" r:id="rId11"/>
     <p:sldId id="266" r:id="rId12"/>
     <p:sldId id="267" r:id="rId13"/>
+    <p:sldId id="270" r:id="rId22"/>
     <p:sldId id="268" r:id="rId14"/>
     <p:sldId id="269" r:id="rId15"/>
   </p:sldIdLst>
@@ -3728,7 +3729,7 @@
                 <a:ea typeface="Calibri" pitchFamily="34" charset="-122"/>
                 <a:cs typeface="Calibri" pitchFamily="34" charset="-120"/>
               </a:rPr>
-              <a:t>12</a:t>
+              <a:t>13</a:t>
             </a:r>
           </a:p>
         </p:txBody>
@@ -4031,6 +4032,438 @@
                 <a:cs typeface="Calibri" pitchFamily="34" charset="-120"/>
               </a:rPr>
               <a:t> — your first Python script and your first notebook.</a:t>
+            </a:r>
+          </a:p>
+        </p:txBody>
+      </p:sp>
+    </p:spTree>
+  </p:cSld>
+  <p:clrMapOvr>
+    <a:masterClrMapping/>
+  </p:clrMapOvr>
+</p:sld>
+</file>
+
+<file path=ppt/slides/slide15.xml><?xml version="1.0" encoding="utf-8"?>
+<p:sld xmlns:a="http://schemas.openxmlformats.org/drawingml/2006/main" xmlns:r="http://schemas.openxmlformats.org/officeDocument/2006/relationships" xmlns:p="http://schemas.openxmlformats.org/presentationml/2006/main">
+  <p:cSld>
+    <p:bg>
+      <p:bgPr>
+        <a:solidFill>
+          <a:srgbClr val="FFFFFF"/>
+        </a:solidFill>
+        <a:effectLst/>
+      </p:bgPr>
+    </p:bg>
+    <p:spTree>
+      <p:nvGrpSpPr>
+        <p:cNvPr id="1" name=""/>
+        <p:cNvGrpSpPr/>
+        <p:nvPr/>
+      </p:nvGrpSpPr>
+      <p:grpSpPr>
+        <a:xfrm>
+          <a:off x="0" y="0"/>
+          <a:ext cx="0" cy="0"/>
+          <a:chOff x="0" y="0"/>
+          <a:chExt cx="0" cy="0"/>
+        </a:xfrm>
+      </p:grpSpPr>
+      <p:sp>
+        <p:nvSpPr>
+          <p:cNvPr id="226" name="Box"/>
+          <p:cNvSpPr/>
+          <p:nvPr/>
+        </p:nvSpPr>
+        <p:spPr>
+          <a:xfrm>
+            <a:off x="457200" y="411480"/>
+            <a:ext cx="2011680" cy="329184"/>
+          </a:xfrm>
+          <a:prstGeom prst="roundRect">
+            <a:avLst>
+              <a:gd name="adj" fmla="val 50000"/>
+            </a:avLst>
+          </a:prstGeom>
+          <a:solidFill>
+            <a:srgbClr val="1E2761"/>
+          </a:solidFill>
+          <a:ln/>
+        </p:spPr>
+        <p:txBody>
+          <a:bodyPr/>
+          <a:lstStyle/>
+          <a:p>
+            <a:endParaRPr lang="nb-NO"/>
+          </a:p>
+        </p:txBody>
+      </p:sp>
+      <p:sp>
+        <p:nvSpPr>
+          <p:cNvPr id="227" name="Text"/>
+          <p:cNvSpPr/>
+          <p:nvPr/>
+        </p:nvSpPr>
+        <p:spPr>
+          <a:xfrm>
+            <a:off x="457200" y="411480"/>
+            <a:ext cx="2011680" cy="329184"/>
+          </a:xfrm>
+          <a:prstGeom prst="rect">
+            <a:avLst/>
+          </a:prstGeom>
+          <a:noFill/>
+          <a:ln/>
+        </p:spPr>
+        <p:txBody>
+          <a:bodyPr wrap="square" rtlCol="0" anchor="ctr"/>
+          <a:lstStyle/>
+          <a:p>
+            <a:pPr marL="0" indent="0" algn="ctr">
+              <a:buNone/>
+            </a:pPr>
+            <a:r>
+              <a:rPr lang="en-US" sz="1100" b="1" kern="0" spc="100" dirty="0">
+                <a:solidFill>
+                  <a:srgbClr val="FFFFFF"/>
+                </a:solidFill>
+                <a:latin typeface="Calibri" pitchFamily="34" charset="0"/>
+                <a:ea typeface="Calibri" pitchFamily="34" charset="-122"/>
+                <a:cs typeface="Calibri" pitchFamily="34" charset="-120"/>
+              </a:rPr>
+              <a:t>CONCEPT</a:t>
+            </a:r>
+          </a:p>
+        </p:txBody>
+      </p:sp>
+      <p:sp>
+        <p:nvSpPr>
+          <p:cNvPr id="228" name="Circle"/>
+          <p:cNvSpPr/>
+          <p:nvPr/>
+        </p:nvSpPr>
+        <p:spPr>
+          <a:xfrm>
+            <a:off x="10771632" y="384048"/>
+            <a:ext cx="822960" cy="822960"/>
+          </a:xfrm>
+          <a:prstGeom prst="ellipse">
+            <a:avLst/>
+          </a:prstGeom>
+          <a:solidFill>
+            <a:srgbClr val="2A3B8F"/>
+          </a:solidFill>
+          <a:ln/>
+        </p:spPr>
+        <p:txBody>
+          <a:bodyPr/>
+          <a:lstStyle/>
+          <a:p>
+            <a:endParaRPr lang="nb-NO"/>
+          </a:p>
+        </p:txBody>
+      </p:sp>
+      <p:pic>
+        <p:nvPicPr>
+          <p:cNvPr id="229" name="Icon" descr="icons/monitor.png"/>
+          <p:cNvPicPr>
+            <a:picLocks noChangeAspect="1"/>
+          </p:cNvPicPr>
+          <p:nvPr/>
+        </p:nvPicPr>
+        <p:blipFill>
+          <a:blip r:embed="rId2"/>
+          <a:stretch>
+            <a:fillRect/>
+          </a:stretch>
+        </p:blipFill>
+        <p:spPr>
+          <a:xfrm>
+            <a:off x="10862158" y="474574"/>
+            <a:ext cx="641909" cy="641909"/>
+          </a:xfrm>
+          <a:prstGeom prst="rect">
+            <a:avLst/>
+          </a:prstGeom>
+        </p:spPr>
+      </p:pic>
+      <p:sp>
+        <p:nvSpPr>
+          <p:cNvPr id="230" name="Text"/>
+          <p:cNvSpPr/>
+          <p:nvPr/>
+        </p:nvSpPr>
+        <p:spPr>
+          <a:xfrm>
+            <a:off x="457200" y="896112"/>
+            <a:ext cx="11274552" cy="822960"/>
+          </a:xfrm>
+          <a:prstGeom prst="rect">
+            <a:avLst/>
+          </a:prstGeom>
+          <a:noFill/>
+          <a:ln/>
+        </p:spPr>
+        <p:txBody>
+          <a:bodyPr wrap="square" rtlCol="0" anchor="t"/>
+          <a:lstStyle/>
+          <a:p>
+            <a:pPr marL="0" indent="0" algn="l">
+              <a:buNone/>
+            </a:pPr>
+            <a:r>
+              <a:rPr lang="en-US" sz="3200" b="1" dirty="0">
+                <a:solidFill>
+                  <a:srgbClr val="1E2761"/>
+                </a:solidFill>
+                <a:latin typeface="Cambria" pitchFamily="34" charset="0"/>
+                <a:ea typeface="Cambria" pitchFamily="34" charset="-122"/>
+                <a:cs typeface="Cambria" pitchFamily="34" charset="-120"/>
+              </a:rPr>
+              <a:t>Meet TECHi</a:t>
+            </a:r>
+          </a:p>
+        </p:txBody>
+      </p:sp>
+      <p:sp>
+        <p:nvSpPr>
+          <p:cNvPr id="231" name="Bullets"/>
+          <p:cNvSpPr/>
+          <p:nvPr/>
+        </p:nvSpPr>
+        <p:spPr>
+          <a:xfrm>
+            <a:off x="822960" y="1920240"/>
+            <a:ext cx="10543032" cy="3200400"/>
+          </a:xfrm>
+          <a:prstGeom prst="rect">
+            <a:avLst/>
+          </a:prstGeom>
+          <a:noFill/>
+          <a:ln/>
+        </p:spPr>
+        <p:txBody>
+          <a:bodyPr wrap="square" rtlCol="0" anchor="t"/>
+          <a:lstStyle/>
+          <a:p>
+            <a:pPr marL="342900" indent="-342900" algn="l">
+              <a:spcAft>
+                <a:spcPts val="1200"/>
+              </a:spcAft>
+              <a:buSzPct val="100000"/>
+              <a:buChar char="•"/>
+            </a:pPr>
+            <a:r>
+              <a:rPr lang="en-US" dirty="0">
+                <a:solidFill>
+                  <a:srgbClr val="1E2761"/>
+                </a:solidFill>
+                <a:latin typeface="Calibri" pitchFamily="34" charset="0"/>
+                <a:ea typeface="Calibri" pitchFamily="34" charset="-122"/>
+                <a:cs typeface="Calibri" pitchFamily="34" charset="-120"/>
+              </a:rPr>
+              <a:t>Built for this course — it knows the lecture material, the exercises, and where we are in the syllabus</a:t>
+            </a:r>
+          </a:p>
+          <a:p>
+            <a:pPr marL="342900" indent="-342900" algn="l">
+              <a:spcAft>
+                <a:spcPts val="1200"/>
+              </a:spcAft>
+              <a:buSzPct val="100000"/>
+              <a:buChar char="•"/>
+            </a:pPr>
+            <a:r>
+              <a:rPr lang="en-US" dirty="0">
+                <a:solidFill>
+                  <a:srgbClr val="1E2761"/>
+                </a:solidFill>
+                <a:latin typeface="Calibri" pitchFamily="34" charset="0"/>
+                <a:ea typeface="Calibri" pitchFamily="34" charset="-122"/>
+                <a:cs typeface="Calibri" pitchFamily="34" charset="-120"/>
+              </a:rPr>
+              <a:t>Privacy-friendly — your conversations are not sent to a commercial AI provider</a:t>
+            </a:r>
+          </a:p>
+          <a:p>
+            <a:pPr marL="342900" indent="-342900" algn="l">
+              <a:spcAft>
+                <a:spcPts val="1200"/>
+              </a:spcAft>
+              <a:buSzPct val="100000"/>
+              <a:buChar char="•"/>
+            </a:pPr>
+            <a:r>
+              <a:rPr lang="en-US" dirty="0">
+                <a:solidFill>
+                  <a:srgbClr val="1E2761"/>
+                </a:solidFill>
+                <a:latin typeface="Calibri" pitchFamily="34" charset="0"/>
+                <a:ea typeface="Calibri" pitchFamily="34" charset="-122"/>
+                <a:cs typeface="Calibri" pitchFamily="34" charset="-120"/>
+              </a:rPr>
+              <a:t>Socratic by design — it will not hand you the code. It asks questions and gives hints, so the thinking stays yours</a:t>
+            </a:r>
+          </a:p>
+          <a:p>
+            <a:pPr marL="342900" indent="-342900" algn="l">
+              <a:spcAft>
+                <a:spcPts val="1200"/>
+              </a:spcAft>
+              <a:buSzPct val="100000"/>
+              <a:buChar char="•"/>
+            </a:pPr>
+            <a:r>
+              <a:rPr lang="en-US" dirty="0">
+                <a:solidFill>
+                  <a:srgbClr val="1E2761"/>
+                </a:solidFill>
+                <a:latin typeface="Calibri" pitchFamily="34" charset="0"/>
+                <a:ea typeface="Calibri" pitchFamily="34" charset="-122"/>
+                <a:cs typeface="Calibri" pitchFamily="34" charset="-120"/>
+              </a:rPr>
+              <a:t>Find it on Canvas under Start here — nothing to install, no account to create</a:t>
+            </a:r>
+          </a:p>
+          <a:p>
+            <a:pPr marL="342900" indent="-342900" algn="l">
+              <a:spcAft>
+                <a:spcPts val="1200"/>
+              </a:spcAft>
+              <a:buSzPct val="100000"/>
+              <a:buChar char="•"/>
+            </a:pPr>
+            <a:r>
+              <a:rPr lang="en-US" dirty="0">
+                <a:solidFill>
+                  <a:srgbClr val="1E2761"/>
+                </a:solidFill>
+                <a:latin typeface="Calibri" pitchFamily="34" charset="0"/>
+                <a:ea typeface="Calibri" pitchFamily="34" charset="-122"/>
+                <a:cs typeface="Calibri" pitchFamily="34" charset="-120"/>
+              </a:rPr>
+              <a:t>You may still use other AI tools. The same guidelines apply, and so does declaring your use</a:t>
+            </a:r>
+          </a:p>
+        </p:txBody>
+      </p:sp>
+      <p:sp>
+        <p:nvSpPr>
+          <p:cNvPr id="232" name="Box"/>
+          <p:cNvSpPr/>
+          <p:nvPr/>
+        </p:nvSpPr>
+        <p:spPr>
+          <a:xfrm>
+            <a:off x="822960" y="5394960"/>
+            <a:ext cx="10543032" cy="640080"/>
+          </a:xfrm>
+          <a:prstGeom prst="roundRect">
+            <a:avLst>
+              <a:gd name="adj" fmla="val 11429"/>
+            </a:avLst>
+          </a:prstGeom>
+          <a:solidFill>
+            <a:srgbClr val="F1F4FB"/>
+          </a:solidFill>
+          <a:ln w="15875">
+            <a:solidFill>
+              <a:srgbClr val="F96167"/>
+            </a:solidFill>
+            <a:prstDash val="solid"/>
+          </a:ln>
+        </p:spPr>
+        <p:txBody>
+          <a:bodyPr/>
+          <a:lstStyle/>
+          <a:p>
+            <a:endParaRPr lang="nb-NO"/>
+          </a:p>
+        </p:txBody>
+      </p:sp>
+      <p:sp>
+        <p:nvSpPr>
+          <p:cNvPr id="233" name="Text"/>
+          <p:cNvSpPr/>
+          <p:nvPr/>
+        </p:nvSpPr>
+        <p:spPr>
+          <a:xfrm>
+            <a:off x="1051560" y="5394960"/>
+            <a:ext cx="10085832" cy="640080"/>
+          </a:xfrm>
+          <a:prstGeom prst="rect">
+            <a:avLst/>
+          </a:prstGeom>
+          <a:noFill/>
+          <a:ln/>
+        </p:spPr>
+        <p:txBody>
+          <a:bodyPr wrap="square" rtlCol="0" anchor="ctr"/>
+          <a:lstStyle/>
+          <a:p>
+            <a:pPr marL="0" indent="0" algn="l">
+              <a:buNone/>
+            </a:pPr>
+            <a:r>
+              <a:rPr lang="en-US" sz="1600" b="1" i="1" dirty="0">
+                <a:solidFill>
+                  <a:srgbClr val="1E2761"/>
+                </a:solidFill>
+                <a:latin typeface="Calibri" pitchFamily="34" charset="0"/>
+                <a:ea typeface="Calibri" pitchFamily="34" charset="-122"/>
+                <a:cs typeface="Calibri" pitchFamily="34" charset="-120"/>
+              </a:rPr>
+              <a:t>It will not give you the answer, and that is the point</a:t>
+            </a:r>
+            <a:r>
+              <a:rPr lang="en-US" sz="1600" i="1" dirty="0">
+                <a:solidFill>
+                  <a:srgbClr val="1E2761"/>
+                </a:solidFill>
+                <a:latin typeface="Calibri" pitchFamily="34" charset="0"/>
+                <a:ea typeface="Calibri" pitchFamily="34" charset="-122"/>
+                <a:cs typeface="Calibri" pitchFamily="34" charset="-120"/>
+              </a:rPr>
+              <a:t>. Try it on something you are genuinely stuck on — that is when it is most useful.</a:t>
+            </a:r>
+          </a:p>
+        </p:txBody>
+      </p:sp>
+      <p:sp>
+        <p:nvSpPr>
+          <p:cNvPr id="234" name="SlideNumber"/>
+          <p:cNvSpPr/>
+          <p:nvPr/>
+        </p:nvSpPr>
+        <p:spPr>
+          <a:xfrm>
+            <a:off x="11274552" y="6492240"/>
+            <a:ext cx="457200" cy="274320"/>
+          </a:xfrm>
+          <a:prstGeom prst="rect">
+            <a:avLst/>
+          </a:prstGeom>
+          <a:noFill/>
+          <a:ln/>
+        </p:spPr>
+        <p:txBody>
+          <a:bodyPr wrap="square" rtlCol="0" anchor="ctr"/>
+          <a:lstStyle/>
+          <a:p>
+            <a:pPr marL="0" indent="0" algn="r">
+              <a:buNone/>
+            </a:pPr>
+            <a:r>
+              <a:rPr lang="en-US" sz="900" dirty="0">
+                <a:solidFill>
+                  <a:srgbClr val="5B6472"/>
+                </a:solidFill>
+                <a:latin typeface="Calibri" pitchFamily="34" charset="0"/>
+                <a:ea typeface="Calibri" pitchFamily="34" charset="-122"/>
+                <a:cs typeface="Calibri" pitchFamily="34" charset="-120"/>
+              </a:rPr>
+              <a:t>12</a:t>
             </a:r>
           </a:p>
         </p:txBody>

</xml_diff>

<commit_message>
Require Miniforge and clarify guides for existing installations
</commit_message>
<xml_diff>
--- a/lectures/00-introduction.pptx
+++ b/lectures/00-introduction.pptx
@@ -17,9 +17,9 @@
     <p:sldId id="265" r:id="rId11"/>
     <p:sldId id="266" r:id="rId12"/>
     <p:sldId id="267" r:id="rId13"/>
-    <p:sldId id="270" r:id="rId22"/>
-    <p:sldId id="268" r:id="rId14"/>
-    <p:sldId id="269" r:id="rId15"/>
+    <p:sldId id="270" r:id="rId14"/>
+    <p:sldId id="268" r:id="rId15"/>
+    <p:sldId id="269" r:id="rId16"/>
   </p:sldIdLst>
   <p:sldSz cx="12192000" cy="6858000"/>
   <p:notesSz cx="6858000" cy="12192000"/>
@@ -136,7 +136,7 @@
   <pc:docChgLst>
     <pc:chgData name="Isabel Montero Hovdahl" userId="e6c00a4d-4ab5-475c-996d-11be2680c122" providerId="ADAL" clId="{492A1D5D-B8BD-4473-8F28-59B786D7141F}"/>
     <pc:docChg chg="undo custSel modSld">
-      <pc:chgData name="Isabel Montero Hovdahl" userId="e6c00a4d-4ab5-475c-996d-11be2680c122" providerId="ADAL" clId="{492A1D5D-B8BD-4473-8F28-59B786D7141F}" dt="2026-08-09T11:38:26.772" v="511" actId="403"/>
+      <pc:chgData name="Isabel Montero Hovdahl" userId="e6c00a4d-4ab5-475c-996d-11be2680c122" providerId="ADAL" clId="{492A1D5D-B8BD-4473-8F28-59B786D7141F}" dt="2026-08-10T07:50:14.778" v="685" actId="6549"/>
       <pc:docMkLst>
         <pc:docMk/>
       </pc:docMkLst>
@@ -372,13 +372,13 @@
         </pc:spChg>
       </pc:sldChg>
       <pc:sldChg chg="modSp mod">
-        <pc:chgData name="Isabel Montero Hovdahl" userId="e6c00a4d-4ab5-475c-996d-11be2680c122" providerId="ADAL" clId="{492A1D5D-B8BD-4473-8F28-59B786D7141F}" dt="2026-08-09T11:34:45.808" v="505" actId="403"/>
+        <pc:chgData name="Isabel Montero Hovdahl" userId="e6c00a4d-4ab5-475c-996d-11be2680c122" providerId="ADAL" clId="{492A1D5D-B8BD-4473-8F28-59B786D7141F}" dt="2026-08-10T07:43:45.158" v="512" actId="20577"/>
         <pc:sldMkLst>
           <pc:docMk/>
           <pc:sldMk cId="0" sldId="265"/>
         </pc:sldMkLst>
         <pc:spChg chg="mod">
-          <ac:chgData name="Isabel Montero Hovdahl" userId="e6c00a4d-4ab5-475c-996d-11be2680c122" providerId="ADAL" clId="{492A1D5D-B8BD-4473-8F28-59B786D7141F}" dt="2026-08-09T11:34:45.808" v="505" actId="403"/>
+          <ac:chgData name="Isabel Montero Hovdahl" userId="e6c00a4d-4ab5-475c-996d-11be2680c122" providerId="ADAL" clId="{492A1D5D-B8BD-4473-8F28-59B786D7141F}" dt="2026-08-10T07:43:45.158" v="512" actId="20577"/>
           <ac:spMkLst>
             <pc:docMk/>
             <pc:sldMk cId="0" sldId="265"/>
@@ -387,7 +387,7 @@
         </pc:spChg>
       </pc:sldChg>
       <pc:sldChg chg="modSp mod">
-        <pc:chgData name="Isabel Montero Hovdahl" userId="e6c00a4d-4ab5-475c-996d-11be2680c122" providerId="ADAL" clId="{492A1D5D-B8BD-4473-8F28-59B786D7141F}" dt="2026-08-09T11:35:07.559" v="506" actId="403"/>
+        <pc:chgData name="Isabel Montero Hovdahl" userId="e6c00a4d-4ab5-475c-996d-11be2680c122" providerId="ADAL" clId="{492A1D5D-B8BD-4473-8F28-59B786D7141F}" dt="2026-08-10T07:43:58.242" v="513" actId="20577"/>
         <pc:sldMkLst>
           <pc:docMk/>
           <pc:sldMk cId="0" sldId="266"/>
@@ -401,7 +401,7 @@
           </ac:spMkLst>
         </pc:spChg>
         <pc:graphicFrameChg chg="modGraphic">
-          <ac:chgData name="Isabel Montero Hovdahl" userId="e6c00a4d-4ab5-475c-996d-11be2680c122" providerId="ADAL" clId="{492A1D5D-B8BD-4473-8F28-59B786D7141F}" dt="2026-08-09T11:35:07.559" v="506" actId="403"/>
+          <ac:chgData name="Isabel Montero Hovdahl" userId="e6c00a4d-4ab5-475c-996d-11be2680c122" providerId="ADAL" clId="{492A1D5D-B8BD-4473-8F28-59B786D7141F}" dt="2026-08-10T07:43:58.242" v="513" actId="20577"/>
           <ac:graphicFrameMkLst>
             <pc:docMk/>
             <pc:sldMk cId="0" sldId="266"/>
@@ -410,13 +410,13 @@
         </pc:graphicFrameChg>
       </pc:sldChg>
       <pc:sldChg chg="modSp mod">
-        <pc:chgData name="Isabel Montero Hovdahl" userId="e6c00a4d-4ab5-475c-996d-11be2680c122" providerId="ADAL" clId="{492A1D5D-B8BD-4473-8F28-59B786D7141F}" dt="2026-08-09T11:35:56.089" v="507" actId="403"/>
+        <pc:chgData name="Isabel Montero Hovdahl" userId="e6c00a4d-4ab5-475c-996d-11be2680c122" providerId="ADAL" clId="{492A1D5D-B8BD-4473-8F28-59B786D7141F}" dt="2026-08-10T07:50:14.778" v="685" actId="6549"/>
         <pc:sldMkLst>
           <pc:docMk/>
           <pc:sldMk cId="0" sldId="267"/>
         </pc:sldMkLst>
         <pc:spChg chg="mod">
-          <ac:chgData name="Isabel Montero Hovdahl" userId="e6c00a4d-4ab5-475c-996d-11be2680c122" providerId="ADAL" clId="{492A1D5D-B8BD-4473-8F28-59B786D7141F}" dt="2026-08-09T11:35:56.089" v="507" actId="403"/>
+          <ac:chgData name="Isabel Montero Hovdahl" userId="e6c00a4d-4ab5-475c-996d-11be2680c122" providerId="ADAL" clId="{492A1D5D-B8BD-4473-8F28-59B786D7141F}" dt="2026-08-10T07:50:14.778" v="685" actId="6549"/>
           <ac:spMkLst>
             <pc:docMk/>
             <pc:sldMk cId="0" sldId="267"/>
@@ -425,7 +425,7 @@
         </pc:spChg>
       </pc:sldChg>
       <pc:sldChg chg="modSp mod">
-        <pc:chgData name="Isabel Montero Hovdahl" userId="e6c00a4d-4ab5-475c-996d-11be2680c122" providerId="ADAL" clId="{492A1D5D-B8BD-4473-8F28-59B786D7141F}" dt="2026-08-09T11:38:26.772" v="511" actId="403"/>
+        <pc:chgData name="Isabel Montero Hovdahl" userId="e6c00a4d-4ab5-475c-996d-11be2680c122" providerId="ADAL" clId="{492A1D5D-B8BD-4473-8F28-59B786D7141F}" dt="2026-08-10T07:48:00.582" v="514" actId="20577"/>
         <pc:sldMkLst>
           <pc:docMk/>
           <pc:sldMk cId="0" sldId="268"/>
@@ -439,7 +439,7 @@
           </ac:spMkLst>
         </pc:spChg>
         <pc:spChg chg="mod">
-          <ac:chgData name="Isabel Montero Hovdahl" userId="e6c00a4d-4ab5-475c-996d-11be2680c122" providerId="ADAL" clId="{492A1D5D-B8BD-4473-8F28-59B786D7141F}" dt="2026-08-09T11:38:10.146" v="509" actId="403"/>
+          <ac:chgData name="Isabel Montero Hovdahl" userId="e6c00a4d-4ab5-475c-996d-11be2680c122" providerId="ADAL" clId="{492A1D5D-B8BD-4473-8F28-59B786D7141F}" dt="2026-08-10T07:48:00.582" v="514" actId="20577"/>
           <ac:spMkLst>
             <pc:docMk/>
             <pc:sldMk cId="0" sldId="268"/>
@@ -1256,7 +1256,7 @@
                 <a:ea typeface="Calibri" pitchFamily="34" charset="-122"/>
                 <a:cs typeface="Calibri" pitchFamily="34" charset="-120"/>
               </a:rPr>
-              <a:t>On Canvas go to Modules — every week links to that week’ s material</a:t>
+              <a:t>On Canvas go to Modules — every week links to that week’s material</a:t>
             </a:r>
           </a:p>
           <a:p>
@@ -1600,7 +1600,7 @@
           <p:nvPr>
             <p:extLst>
               <p:ext uri="{D42A27DB-BD31-4B8C-83A1-F6EECF244321}">
-                <p14:modId xmlns:p14="http://schemas.microsoft.com/office/powerpoint/2010/main" val="3368776687"/>
+                <p14:modId xmlns:p14="http://schemas.microsoft.com/office/powerpoint/2010/main" val="2144282742"/>
               </p:ext>
             </p:extLst>
           </p:nvPr>
@@ -2224,7 +2224,7 @@
                           <a:ea typeface="Calibri" pitchFamily="34" charset="-122"/>
                           <a:cs typeface="Calibri" pitchFamily="34" charset="-120"/>
                         </a:rPr>
-                        <a:t>Term paper, groups of 2– 3, 3 days</a:t>
+                        <a:t>Term paper, groups of 2–3, 3 days</a:t>
                       </a:r>
                     </a:p>
                   </a:txBody>
@@ -2866,7 +2866,7 @@
                 <a:ea typeface="Calibri" pitchFamily="34" charset="-122"/>
                 <a:cs typeface="Calibri" pitchFamily="34" charset="-120"/>
               </a:rPr>
-              <a:t>❌ Use it to keep pace when you have fallen behind — this hides the gap, it does not close it</a:t>
+              <a:t>❌ Use it to keep up rather than learn — the gap only shows up in the exam, when you are on your own</a:t>
             </a:r>
           </a:p>
           <a:p>
@@ -3047,7 +3047,7 @@
       </p:grpSpPr>
       <p:sp>
         <p:nvSpPr>
-          <p:cNvPr id="235" name="Box"/>
+          <p:cNvPr id="226" name="Box"/>
           <p:cNvSpPr/>
           <p:nvPr/>
         </p:nvSpPr>
@@ -3076,7 +3076,7 @@
       </p:sp>
       <p:sp>
         <p:nvSpPr>
-          <p:cNvPr id="236" name="Text"/>
+          <p:cNvPr id="227" name="Text"/>
           <p:cNvSpPr/>
           <p:nvPr/>
         </p:nvSpPr>
@@ -3107,14 +3107,14 @@
                 <a:ea typeface="Calibri" pitchFamily="34" charset="-122"/>
                 <a:cs typeface="Calibri" pitchFamily="34" charset="-120"/>
               </a:rPr>
-              <a:t>SETUP</a:t>
-            </a:r>
-          </a:p>
-        </p:txBody>
-      </p:sp>
-      <p:sp>
-        <p:nvSpPr>
-          <p:cNvPr id="237" name="Circle"/>
+              <a:t>CONCEPT</a:t>
+            </a:r>
+          </a:p>
+        </p:txBody>
+      </p:sp>
+      <p:sp>
+        <p:nvSpPr>
+          <p:cNvPr id="228" name="Circle"/>
           <p:cNvSpPr/>
           <p:nvPr/>
         </p:nvSpPr>
@@ -3141,7 +3141,7 @@
       </p:sp>
       <p:pic>
         <p:nvPicPr>
-          <p:cNvPr id="238" name="Icon" descr="icons/play.png"/>
+          <p:cNvPr id="229" name="Icon" descr="icons/monitor.png"/>
           <p:cNvPicPr>
             <a:picLocks noChangeAspect="1"/>
           </p:cNvPicPr>
@@ -3165,7 +3165,7 @@
       </p:pic>
       <p:sp>
         <p:nvSpPr>
-          <p:cNvPr id="239" name="Text"/>
+          <p:cNvPr id="230" name="Text"/>
           <p:cNvSpPr/>
           <p:nvPr/>
         </p:nvSpPr>
@@ -3196,48 +3196,21 @@
                 <a:ea typeface="Cambria" pitchFamily="34" charset="-122"/>
                 <a:cs typeface="Cambria" pitchFamily="34" charset="-120"/>
               </a:rPr>
-              <a:t>Before Friday</a:t>
-            </a:r>
-          </a:p>
-        </p:txBody>
-      </p:sp>
-      <p:sp>
-        <p:nvSpPr>
-          <p:cNvPr id="240" name="Circle"/>
-          <p:cNvSpPr/>
-          <p:nvPr/>
-        </p:nvSpPr>
-        <p:spPr>
-          <a:xfrm>
-            <a:off x="822960" y="2103120"/>
-            <a:ext cx="384048" cy="384048"/>
-          </a:xfrm>
-          <a:prstGeom prst="ellipse">
-            <a:avLst/>
-          </a:prstGeom>
-          <a:solidFill>
-            <a:srgbClr val="F96167"/>
-          </a:solidFill>
-          <a:ln/>
-        </p:spPr>
-        <p:txBody>
-          <a:bodyPr/>
-          <a:lstStyle/>
-          <a:p>
-            <a:endParaRPr lang="nb-NO"/>
-          </a:p>
-        </p:txBody>
-      </p:sp>
-      <p:sp>
-        <p:nvSpPr>
-          <p:cNvPr id="241" name="Text"/>
-          <p:cNvSpPr/>
-          <p:nvPr/>
-        </p:nvSpPr>
-        <p:spPr>
-          <a:xfrm>
-            <a:off x="822960" y="2103120"/>
-            <a:ext cx="384048" cy="384048"/>
+              <a:t>Meet TECHi</a:t>
+            </a:r>
+          </a:p>
+        </p:txBody>
+      </p:sp>
+      <p:sp>
+        <p:nvSpPr>
+          <p:cNvPr id="231" name="Bullets"/>
+          <p:cNvSpPr/>
+          <p:nvPr/>
+        </p:nvSpPr>
+        <p:spPr>
+          <a:xfrm>
+            <a:off x="822960" y="1920240"/>
+            <a:ext cx="10543032" cy="3200400"/>
           </a:xfrm>
           <a:prstGeom prst="rect">
             <a:avLst/>
@@ -3246,49 +3219,35 @@
           <a:ln/>
         </p:spPr>
         <p:txBody>
-          <a:bodyPr wrap="square" rtlCol="0" anchor="ctr"/>
-          <a:lstStyle/>
-          <a:p>
-            <a:pPr marL="0" indent="0" algn="ctr">
-              <a:buNone/>
+          <a:bodyPr wrap="square" rtlCol="0" anchor="t"/>
+          <a:lstStyle/>
+          <a:p>
+            <a:pPr marL="342900" indent="-342900" algn="l">
+              <a:spcAft>
+                <a:spcPts val="1200"/>
+              </a:spcAft>
+              <a:buSzPct val="100000"/>
+              <a:buChar char="•"/>
             </a:pPr>
             <a:r>
-              <a:rPr lang="en-US" sz="1500" b="1" dirty="0">
-                <a:solidFill>
-                  <a:srgbClr val="FFFFFF"/>
+              <a:rPr lang="en-US" dirty="0">
+                <a:solidFill>
+                  <a:srgbClr val="1E2761"/>
                 </a:solidFill>
                 <a:latin typeface="Calibri" pitchFamily="34" charset="0"/>
                 <a:ea typeface="Calibri" pitchFamily="34" charset="-122"/>
                 <a:cs typeface="Calibri" pitchFamily="34" charset="-120"/>
               </a:rPr>
-              <a:t>1</a:t>
-            </a:r>
-          </a:p>
-        </p:txBody>
-      </p:sp>
-      <p:sp>
-        <p:nvSpPr>
-          <p:cNvPr id="242" name="Text"/>
-          <p:cNvSpPr/>
-          <p:nvPr/>
-        </p:nvSpPr>
-        <p:spPr>
-          <a:xfrm>
-            <a:off x="1371600" y="2075688"/>
-            <a:ext cx="9994392" cy="457200"/>
-          </a:xfrm>
-          <a:prstGeom prst="rect">
-            <a:avLst/>
-          </a:prstGeom>
-          <a:noFill/>
-          <a:ln/>
-        </p:spPr>
-        <p:txBody>
-          <a:bodyPr wrap="square" rtlCol="0" anchor="ctr"/>
-          <a:lstStyle/>
-          <a:p>
-            <a:pPr marL="0" indent="0" algn="l">
-              <a:buNone/>
+              <a:t>Built for this course — it knows the lecture material, the exercises, and where we are in the syllabus</a:t>
+            </a:r>
+          </a:p>
+          <a:p>
+            <a:pPr marL="342900" indent="-342900" algn="l">
+              <a:spcAft>
+                <a:spcPts val="1200"/>
+              </a:spcAft>
+              <a:buSzPct val="100000"/>
+              <a:buChar char="•"/>
             </a:pPr>
             <a:r>
               <a:rPr lang="en-US" dirty="0">
@@ -3299,99 +3258,36 @@
                 <a:ea typeface="Calibri" pitchFamily="34" charset="-122"/>
                 <a:cs typeface="Calibri" pitchFamily="34" charset="-120"/>
               </a:rPr>
-              <a:t>Check that VS Code, Git and Miniforge all work — the checklist takes two minutes</a:t>
-            </a:r>
-          </a:p>
-        </p:txBody>
-      </p:sp>
-      <p:sp>
-        <p:nvSpPr>
-          <p:cNvPr id="243" name="Circle"/>
-          <p:cNvSpPr/>
-          <p:nvPr/>
-        </p:nvSpPr>
-        <p:spPr>
-          <a:xfrm>
-            <a:off x="822960" y="2788920"/>
-            <a:ext cx="384048" cy="384048"/>
-          </a:xfrm>
-          <a:prstGeom prst="ellipse">
-            <a:avLst/>
-          </a:prstGeom>
-          <a:solidFill>
-            <a:srgbClr val="F96167"/>
-          </a:solidFill>
-          <a:ln/>
-        </p:spPr>
-        <p:txBody>
-          <a:bodyPr/>
-          <a:lstStyle/>
-          <a:p>
-            <a:endParaRPr lang="nb-NO"/>
-          </a:p>
-        </p:txBody>
-      </p:sp>
-      <p:sp>
-        <p:nvSpPr>
-          <p:cNvPr id="244" name="Text"/>
-          <p:cNvSpPr/>
-          <p:nvPr/>
-        </p:nvSpPr>
-        <p:spPr>
-          <a:xfrm>
-            <a:off x="822960" y="2788920"/>
-            <a:ext cx="384048" cy="384048"/>
-          </a:xfrm>
-          <a:prstGeom prst="rect">
-            <a:avLst/>
-          </a:prstGeom>
-          <a:noFill/>
-          <a:ln/>
-        </p:spPr>
-        <p:txBody>
-          <a:bodyPr wrap="square" rtlCol="0" anchor="ctr"/>
-          <a:lstStyle/>
-          <a:p>
-            <a:pPr marL="0" indent="0" algn="ctr">
-              <a:buNone/>
+              <a:t>Privacy-friendly — your conversations are not sent to a commercial AI provider</a:t>
+            </a:r>
+          </a:p>
+          <a:p>
+            <a:pPr marL="342900" indent="-342900" algn="l">
+              <a:spcAft>
+                <a:spcPts val="1200"/>
+              </a:spcAft>
+              <a:buSzPct val="100000"/>
+              <a:buChar char="•"/>
             </a:pPr>
             <a:r>
-              <a:rPr lang="en-US" sz="1500" b="1" dirty="0">
-                <a:solidFill>
-                  <a:srgbClr val="FFFFFF"/>
+              <a:rPr lang="en-US" dirty="0">
+                <a:solidFill>
+                  <a:srgbClr val="1E2761"/>
                 </a:solidFill>
                 <a:latin typeface="Calibri" pitchFamily="34" charset="0"/>
                 <a:ea typeface="Calibri" pitchFamily="34" charset="-122"/>
                 <a:cs typeface="Calibri" pitchFamily="34" charset="-120"/>
               </a:rPr>
-              <a:t>2</a:t>
-            </a:r>
-          </a:p>
-        </p:txBody>
-      </p:sp>
-      <p:sp>
-        <p:nvSpPr>
-          <p:cNvPr id="245" name="Text"/>
-          <p:cNvSpPr/>
-          <p:nvPr/>
-        </p:nvSpPr>
-        <p:spPr>
-          <a:xfrm>
-            <a:off x="1371600" y="2761488"/>
-            <a:ext cx="9994392" cy="457200"/>
-          </a:xfrm>
-          <a:prstGeom prst="rect">
-            <a:avLst/>
-          </a:prstGeom>
-          <a:noFill/>
-          <a:ln/>
-        </p:spPr>
-        <p:txBody>
-          <a:bodyPr wrap="square" rtlCol="0" anchor="ctr"/>
-          <a:lstStyle/>
-          <a:p>
-            <a:pPr marL="0" indent="0" algn="l">
-              <a:buNone/>
+              <a:t>Socratic by design — it will not hand you the code. It asks questions and gives hints, so the thinking stays yours</a:t>
+            </a:r>
+          </a:p>
+          <a:p>
+            <a:pPr marL="342900" indent="-342900" algn="l">
+              <a:spcAft>
+                <a:spcPts val="1200"/>
+              </a:spcAft>
+              <a:buSzPct val="100000"/>
+              <a:buChar char="•"/>
             </a:pPr>
             <a:r>
               <a:rPr lang="en-US" dirty="0">
@@ -3402,220 +3298,34 @@
                 <a:ea typeface="Calibri" pitchFamily="34" charset="-122"/>
                 <a:cs typeface="Calibri" pitchFamily="34" charset="-120"/>
               </a:rPr>
-              <a:t>Open Canvas, go to Modules, and find this week’ s links</a:t>
-            </a:r>
-          </a:p>
-        </p:txBody>
-      </p:sp>
-      <p:sp>
-        <p:nvSpPr>
-          <p:cNvPr id="246" name="Circle"/>
-          <p:cNvSpPr/>
-          <p:nvPr/>
-        </p:nvSpPr>
-        <p:spPr>
-          <a:xfrm>
-            <a:off x="822960" y="3474720"/>
-            <a:ext cx="384048" cy="384048"/>
-          </a:xfrm>
-          <a:prstGeom prst="ellipse">
-            <a:avLst/>
-          </a:prstGeom>
-          <a:solidFill>
-            <a:srgbClr val="F96167"/>
-          </a:solidFill>
-          <a:ln/>
-        </p:spPr>
-        <p:txBody>
-          <a:bodyPr/>
-          <a:lstStyle/>
-          <a:p>
-            <a:endParaRPr lang="nb-NO"/>
-          </a:p>
-        </p:txBody>
-      </p:sp>
-      <p:sp>
-        <p:nvSpPr>
-          <p:cNvPr id="247" name="Text"/>
-          <p:cNvSpPr/>
-          <p:nvPr/>
-        </p:nvSpPr>
-        <p:spPr>
-          <a:xfrm>
-            <a:off x="822960" y="3474720"/>
-            <a:ext cx="384048" cy="384048"/>
-          </a:xfrm>
-          <a:prstGeom prst="rect">
-            <a:avLst/>
-          </a:prstGeom>
-          <a:noFill/>
-          <a:ln/>
-        </p:spPr>
-        <p:txBody>
-          <a:bodyPr wrap="square" rtlCol="0" anchor="ctr"/>
-          <a:lstStyle/>
-          <a:p>
-            <a:pPr marL="0" indent="0" algn="ctr">
-              <a:buNone/>
+              <a:t>Find it on Canvas under Start here — nothing to install, no account to create</a:t>
+            </a:r>
+          </a:p>
+          <a:p>
+            <a:pPr marL="342900" indent="-342900" algn="l">
+              <a:spcAft>
+                <a:spcPts val="1200"/>
+              </a:spcAft>
+              <a:buSzPct val="100000"/>
+              <a:buChar char="•"/>
             </a:pPr>
             <a:r>
-              <a:rPr lang="en-US" sz="1500" b="1" dirty="0">
-                <a:solidFill>
-                  <a:srgbClr val="FFFFFF"/>
+              <a:rPr lang="en-US" dirty="0">
+                <a:solidFill>
+                  <a:srgbClr val="1E2761"/>
                 </a:solidFill>
                 <a:latin typeface="Calibri" pitchFamily="34" charset="0"/>
                 <a:ea typeface="Calibri" pitchFamily="34" charset="-122"/>
                 <a:cs typeface="Calibri" pitchFamily="34" charset="-120"/>
               </a:rPr>
-              <a:t>3</a:t>
-            </a:r>
-          </a:p>
-        </p:txBody>
-      </p:sp>
-      <p:sp>
-        <p:nvSpPr>
-          <p:cNvPr id="248" name="Text"/>
-          <p:cNvSpPr/>
-          <p:nvPr/>
-        </p:nvSpPr>
-        <p:spPr>
-          <a:xfrm>
-            <a:off x="1371600" y="3447288"/>
-            <a:ext cx="9994392" cy="457200"/>
-          </a:xfrm>
-          <a:prstGeom prst="rect">
-            <a:avLst/>
-          </a:prstGeom>
-          <a:noFill/>
-          <a:ln/>
-        </p:spPr>
-        <p:txBody>
-          <a:bodyPr wrap="square" rtlCol="0" anchor="ctr"/>
-          <a:lstStyle/>
-          <a:p>
-            <a:pPr marL="0" indent="0" algn="l">
-              <a:buNone/>
-            </a:pPr>
-            <a:r>
-              <a:rPr lang="en-US" dirty="0">
-                <a:solidFill>
-                  <a:srgbClr val="1E2761"/>
-                </a:solidFill>
-                <a:latin typeface="Calibri" pitchFamily="34" charset="0"/>
-                <a:ea typeface="Calibri" pitchFamily="34" charset="-122"/>
-                <a:cs typeface="Calibri" pitchFamily="34" charset="-120"/>
-              </a:rPr>
-              <a:t>Read the AI guidelines — five minutes, and it will change how you work all semester</a:t>
-            </a:r>
-          </a:p>
-        </p:txBody>
-      </p:sp>
-      <p:sp>
-        <p:nvSpPr>
-          <p:cNvPr id="249" name="Circle"/>
-          <p:cNvSpPr/>
-          <p:nvPr/>
-        </p:nvSpPr>
-        <p:spPr>
-          <a:xfrm>
-            <a:off x="822960" y="4160520"/>
-            <a:ext cx="384048" cy="384048"/>
-          </a:xfrm>
-          <a:prstGeom prst="ellipse">
-            <a:avLst/>
-          </a:prstGeom>
-          <a:solidFill>
-            <a:srgbClr val="F96167"/>
-          </a:solidFill>
-          <a:ln/>
-        </p:spPr>
-        <p:txBody>
-          <a:bodyPr/>
-          <a:lstStyle/>
-          <a:p>
-            <a:endParaRPr lang="nb-NO"/>
-          </a:p>
-        </p:txBody>
-      </p:sp>
-      <p:sp>
-        <p:nvSpPr>
-          <p:cNvPr id="250" name="Text"/>
-          <p:cNvSpPr/>
-          <p:nvPr/>
-        </p:nvSpPr>
-        <p:spPr>
-          <a:xfrm>
-            <a:off x="822960" y="4160520"/>
-            <a:ext cx="384048" cy="384048"/>
-          </a:xfrm>
-          <a:prstGeom prst="rect">
-            <a:avLst/>
-          </a:prstGeom>
-          <a:noFill/>
-          <a:ln/>
-        </p:spPr>
-        <p:txBody>
-          <a:bodyPr wrap="square" rtlCol="0" anchor="ctr"/>
-          <a:lstStyle/>
-          <a:p>
-            <a:pPr marL="0" indent="0" algn="ctr">
-              <a:buNone/>
-            </a:pPr>
-            <a:r>
-              <a:rPr lang="en-US" sz="1500" b="1" dirty="0">
-                <a:solidFill>
-                  <a:srgbClr val="FFFFFF"/>
-                </a:solidFill>
-                <a:latin typeface="Calibri" pitchFamily="34" charset="0"/>
-                <a:ea typeface="Calibri" pitchFamily="34" charset="-122"/>
-                <a:cs typeface="Calibri" pitchFamily="34" charset="-120"/>
-              </a:rPr>
-              <a:t>4</a:t>
-            </a:r>
-          </a:p>
-        </p:txBody>
-      </p:sp>
-      <p:sp>
-        <p:nvSpPr>
-          <p:cNvPr id="251" name="Text"/>
-          <p:cNvSpPr/>
-          <p:nvPr/>
-        </p:nvSpPr>
-        <p:spPr>
-          <a:xfrm>
-            <a:off x="1371600" y="4133088"/>
-            <a:ext cx="9994392" cy="457200"/>
-          </a:xfrm>
-          <a:prstGeom prst="rect">
-            <a:avLst/>
-          </a:prstGeom>
-          <a:noFill/>
-          <a:ln/>
-        </p:spPr>
-        <p:txBody>
-          <a:bodyPr wrap="square" rtlCol="0" anchor="ctr"/>
-          <a:lstStyle/>
-          <a:p>
-            <a:pPr marL="0" indent="0" algn="l">
-              <a:buNone/>
-            </a:pPr>
-            <a:r>
-              <a:rPr lang="en-US" dirty="0">
-                <a:solidFill>
-                  <a:srgbClr val="1E2761"/>
-                </a:solidFill>
-                <a:latin typeface="Calibri" pitchFamily="34" charset="0"/>
-                <a:ea typeface="Calibri" pitchFamily="34" charset="-122"/>
-                <a:cs typeface="Calibri" pitchFamily="34" charset="-120"/>
-              </a:rPr>
-              <a:t>Bring your laptop to the workshop: Friday 12:15, aud. B</a:t>
-            </a:r>
-          </a:p>
-        </p:txBody>
-      </p:sp>
-      <p:sp>
-        <p:nvSpPr>
-          <p:cNvPr id="252" name="Box"/>
+              <a:t>You may still use other AI tools. The same guidelines apply, and so does declaring your use</a:t>
+            </a:r>
+          </a:p>
+        </p:txBody>
+      </p:sp>
+      <p:sp>
+        <p:nvSpPr>
+          <p:cNvPr id="232" name="Box"/>
           <p:cNvSpPr/>
           <p:nvPr/>
         </p:nvSpPr>
@@ -3649,7 +3359,7 @@
       </p:sp>
       <p:sp>
         <p:nvSpPr>
-          <p:cNvPr id="253" name="Text"/>
+          <p:cNvPr id="233" name="Text"/>
           <p:cNvSpPr/>
           <p:nvPr/>
         </p:nvSpPr>
@@ -3680,7 +3390,7 @@
                 <a:ea typeface="Calibri" pitchFamily="34" charset="-122"/>
                 <a:cs typeface="Calibri" pitchFamily="34" charset="-120"/>
               </a:rPr>
-              <a:t>Nothing to prepare beyond this</a:t>
+              <a:t>It will not give you the answer, and that is the point</a:t>
             </a:r>
             <a:r>
               <a:rPr lang="en-US" sz="1600" i="1" dirty="0">
@@ -3691,14 +3401,14 @@
                 <a:ea typeface="Calibri" pitchFamily="34" charset="-122"/>
                 <a:cs typeface="Calibri" pitchFamily="34" charset="-120"/>
               </a:rPr>
-              <a:t>. Turn up on Friday and we start writing code.</a:t>
-            </a:r>
-          </a:p>
-        </p:txBody>
-      </p:sp>
-      <p:sp>
-        <p:nvSpPr>
-          <p:cNvPr id="254" name="SlideNumber"/>
+              <a:t>. Try it on something you are genuinely stuck on — that is when it is most useful.</a:t>
+            </a:r>
+          </a:p>
+        </p:txBody>
+      </p:sp>
+      <p:sp>
+        <p:nvSpPr>
+          <p:cNvPr id="234" name="SlideNumber"/>
           <p:cNvSpPr/>
           <p:nvPr/>
         </p:nvSpPr>
@@ -3729,7 +3439,7 @@
                 <a:ea typeface="Calibri" pitchFamily="34" charset="-122"/>
                 <a:cs typeface="Calibri" pitchFamily="34" charset="-120"/>
               </a:rPr>
-              <a:t>13</a:t>
+              <a:t>12</a:t>
             </a:r>
           </a:p>
         </p:txBody>
@@ -3769,14 +3479,81 @@
       </p:grpSpPr>
       <p:sp>
         <p:nvSpPr>
-          <p:cNvPr id="255" name="Circle"/>
-          <p:cNvSpPr/>
-          <p:nvPr/>
-        </p:nvSpPr>
-        <p:spPr>
-          <a:xfrm>
-            <a:off x="5637276" y="1051560"/>
-            <a:ext cx="914400" cy="914400"/>
+          <p:cNvPr id="235" name="Box"/>
+          <p:cNvSpPr/>
+          <p:nvPr/>
+        </p:nvSpPr>
+        <p:spPr>
+          <a:xfrm>
+            <a:off x="457200" y="411480"/>
+            <a:ext cx="2011680" cy="329184"/>
+          </a:xfrm>
+          <a:prstGeom prst="roundRect">
+            <a:avLst>
+              <a:gd name="adj" fmla="val 50000"/>
+            </a:avLst>
+          </a:prstGeom>
+          <a:solidFill>
+            <a:srgbClr val="1E2761"/>
+          </a:solidFill>
+          <a:ln/>
+        </p:spPr>
+        <p:txBody>
+          <a:bodyPr/>
+          <a:lstStyle/>
+          <a:p>
+            <a:endParaRPr lang="nb-NO"/>
+          </a:p>
+        </p:txBody>
+      </p:sp>
+      <p:sp>
+        <p:nvSpPr>
+          <p:cNvPr id="236" name="Text"/>
+          <p:cNvSpPr/>
+          <p:nvPr/>
+        </p:nvSpPr>
+        <p:spPr>
+          <a:xfrm>
+            <a:off x="457200" y="411480"/>
+            <a:ext cx="2011680" cy="329184"/>
+          </a:xfrm>
+          <a:prstGeom prst="rect">
+            <a:avLst/>
+          </a:prstGeom>
+          <a:noFill/>
+          <a:ln/>
+        </p:spPr>
+        <p:txBody>
+          <a:bodyPr wrap="square" rtlCol="0" anchor="ctr"/>
+          <a:lstStyle/>
+          <a:p>
+            <a:pPr marL="0" indent="0" algn="ctr">
+              <a:buNone/>
+            </a:pPr>
+            <a:r>
+              <a:rPr lang="en-US" sz="1100" b="1" kern="0" spc="100" dirty="0">
+                <a:solidFill>
+                  <a:srgbClr val="FFFFFF"/>
+                </a:solidFill>
+                <a:latin typeface="Calibri" pitchFamily="34" charset="0"/>
+                <a:ea typeface="Calibri" pitchFamily="34" charset="-122"/>
+                <a:cs typeface="Calibri" pitchFamily="34" charset="-120"/>
+              </a:rPr>
+              <a:t>SETUP</a:t>
+            </a:r>
+          </a:p>
+        </p:txBody>
+      </p:sp>
+      <p:sp>
+        <p:nvSpPr>
+          <p:cNvPr id="237" name="Circle"/>
+          <p:cNvSpPr/>
+          <p:nvPr/>
+        </p:nvSpPr>
+        <p:spPr>
+          <a:xfrm>
+            <a:off x="10771632" y="384048"/>
+            <a:ext cx="822960" cy="822960"/>
           </a:xfrm>
           <a:prstGeom prst="ellipse">
             <a:avLst/>
@@ -3796,7 +3573,7 @@
       </p:sp>
       <p:pic>
         <p:nvPicPr>
-          <p:cNvPr id="256" name="Icon" descr="icons/check_circle.png"/>
+          <p:cNvPr id="238" name="Icon" descr="icons/play.png"/>
           <p:cNvPicPr>
             <a:picLocks noChangeAspect="1"/>
           </p:cNvPicPr>
@@ -3810,8 +3587,8 @@
         </p:blipFill>
         <p:spPr>
           <a:xfrm>
-            <a:off x="5774436" y="1190460"/>
-            <a:ext cx="640080" cy="640080"/>
+            <a:off x="10862158" y="474574"/>
+            <a:ext cx="641909" cy="641909"/>
           </a:xfrm>
           <a:prstGeom prst="rect">
             <a:avLst/>
@@ -3820,14 +3597,79 @@
       </p:pic>
       <p:sp>
         <p:nvSpPr>
-          <p:cNvPr id="257" name="Text"/>
-          <p:cNvSpPr/>
-          <p:nvPr/>
-        </p:nvSpPr>
-        <p:spPr>
-          <a:xfrm>
-            <a:off x="731520" y="1921400"/>
-            <a:ext cx="10725912" cy="640080"/>
+          <p:cNvPr id="239" name="Text"/>
+          <p:cNvSpPr/>
+          <p:nvPr/>
+        </p:nvSpPr>
+        <p:spPr>
+          <a:xfrm>
+            <a:off x="457200" y="896112"/>
+            <a:ext cx="11274552" cy="822960"/>
+          </a:xfrm>
+          <a:prstGeom prst="rect">
+            <a:avLst/>
+          </a:prstGeom>
+          <a:noFill/>
+          <a:ln/>
+        </p:spPr>
+        <p:txBody>
+          <a:bodyPr wrap="square" rtlCol="0" anchor="t"/>
+          <a:lstStyle/>
+          <a:p>
+            <a:pPr marL="0" indent="0" algn="l">
+              <a:buNone/>
+            </a:pPr>
+            <a:r>
+              <a:rPr lang="en-US" sz="3200" b="1" dirty="0">
+                <a:solidFill>
+                  <a:srgbClr val="1E2761"/>
+                </a:solidFill>
+                <a:latin typeface="Cambria" pitchFamily="34" charset="0"/>
+                <a:ea typeface="Cambria" pitchFamily="34" charset="-122"/>
+                <a:cs typeface="Cambria" pitchFamily="34" charset="-120"/>
+              </a:rPr>
+              <a:t>Before Friday</a:t>
+            </a:r>
+          </a:p>
+        </p:txBody>
+      </p:sp>
+      <p:sp>
+        <p:nvSpPr>
+          <p:cNvPr id="240" name="Circle"/>
+          <p:cNvSpPr/>
+          <p:nvPr/>
+        </p:nvSpPr>
+        <p:spPr>
+          <a:xfrm>
+            <a:off x="822960" y="2103120"/>
+            <a:ext cx="384048" cy="384048"/>
+          </a:xfrm>
+          <a:prstGeom prst="ellipse">
+            <a:avLst/>
+          </a:prstGeom>
+          <a:solidFill>
+            <a:srgbClr val="F96167"/>
+          </a:solidFill>
+          <a:ln/>
+        </p:spPr>
+        <p:txBody>
+          <a:bodyPr/>
+          <a:lstStyle/>
+          <a:p>
+            <a:endParaRPr lang="nb-NO"/>
+          </a:p>
+        </p:txBody>
+      </p:sp>
+      <p:sp>
+        <p:nvSpPr>
+          <p:cNvPr id="241" name="Text"/>
+          <p:cNvSpPr/>
+          <p:nvPr/>
+        </p:nvSpPr>
+        <p:spPr>
+          <a:xfrm>
+            <a:off x="822960" y="2103120"/>
+            <a:ext cx="384048" cy="384048"/>
           </a:xfrm>
           <a:prstGeom prst="rect">
             <a:avLst/>
@@ -3843,69 +3685,45 @@
               <a:buNone/>
             </a:pPr>
             <a:r>
-              <a:rPr lang="en-US" sz="3200" b="1" dirty="0">
-                <a:solidFill>
-                  <a:srgbClr val="1E2761"/>
-                </a:solidFill>
-                <a:latin typeface="Cambria" pitchFamily="34" charset="0"/>
-                <a:ea typeface="Cambria" pitchFamily="34" charset="-122"/>
-                <a:cs typeface="Cambria" pitchFamily="34" charset="-120"/>
-              </a:rPr>
-              <a:t>See You on Friday</a:t>
-            </a:r>
-          </a:p>
-        </p:txBody>
-      </p:sp>
-      <p:sp>
-        <p:nvSpPr>
-          <p:cNvPr id="258" name="Bullets"/>
-          <p:cNvSpPr/>
-          <p:nvPr/>
-        </p:nvSpPr>
-        <p:spPr>
-          <a:xfrm>
-            <a:off x="2194560" y="2744360"/>
-            <a:ext cx="7799832" cy="2011680"/>
-          </a:xfrm>
-          <a:prstGeom prst="rect">
-            <a:avLst/>
-          </a:prstGeom>
-          <a:noFill/>
-          <a:ln/>
-        </p:spPr>
-        <p:txBody>
-          <a:bodyPr wrap="square" rtlCol="0" anchor="t"/>
-          <a:lstStyle/>
-          <a:p>
-            <a:pPr marL="342900" indent="-342900" algn="l">
-              <a:spcAft>
-                <a:spcPts val="1200"/>
-              </a:spcAft>
-              <a:buSzPct val="100000"/>
-              <a:buChar char="•"/>
-            </a:pPr>
-            <a:r>
-              <a:rPr lang="en-US" sz="1600" dirty="0">
-                <a:solidFill>
-                  <a:srgbClr val="1E2761"/>
+              <a:rPr lang="en-US" sz="1500" b="1" dirty="0">
+                <a:solidFill>
+                  <a:srgbClr val="FFFFFF"/>
                 </a:solidFill>
                 <a:latin typeface="Calibri" pitchFamily="34" charset="0"/>
                 <a:ea typeface="Calibri" pitchFamily="34" charset="-122"/>
                 <a:cs typeface="Calibri" pitchFamily="34" charset="-120"/>
               </a:rPr>
-              <a:t>Lectures Wednesdays 08:15 · Workshops Fridays 12:15 · aud. B</a:t>
-            </a:r>
-          </a:p>
-          <a:p>
-            <a:pPr marL="342900" indent="-342900" algn="l">
-              <a:spcAft>
-                <a:spcPts val="1200"/>
-              </a:spcAft>
-              <a:buSzPct val="100000"/>
-              <a:buChar char="•"/>
+              <a:t>1</a:t>
+            </a:r>
+          </a:p>
+        </p:txBody>
+      </p:sp>
+      <p:sp>
+        <p:nvSpPr>
+          <p:cNvPr id="242" name="Text"/>
+          <p:cNvSpPr/>
+          <p:nvPr/>
+        </p:nvSpPr>
+        <p:spPr>
+          <a:xfrm>
+            <a:off x="1371600" y="2075688"/>
+            <a:ext cx="9994392" cy="457200"/>
+          </a:xfrm>
+          <a:prstGeom prst="rect">
+            <a:avLst/>
+          </a:prstGeom>
+          <a:noFill/>
+          <a:ln/>
+        </p:spPr>
+        <p:txBody>
+          <a:bodyPr wrap="square" rtlCol="0" anchor="ctr"/>
+          <a:lstStyle/>
+          <a:p>
+            <a:pPr marL="0" indent="0" algn="l">
+              <a:buNone/>
             </a:pPr>
             <a:r>
-              <a:rPr lang="en-US" sz="1600" dirty="0">
+              <a:rPr lang="en-US" dirty="0">
                 <a:solidFill>
                   <a:srgbClr val="1E2761"/>
                 </a:solidFill>
@@ -3913,39 +3731,102 @@
                 <a:ea typeface="Calibri" pitchFamily="34" charset="-122"/>
                 <a:cs typeface="Calibri" pitchFamily="34" charset="-120"/>
               </a:rPr>
-              <a:t>All material on GitHub, linked from Canvas — Modules</a:t>
-            </a:r>
-          </a:p>
-          <a:p>
-            <a:pPr marL="342900" indent="-342900" algn="l">
-              <a:spcAft>
-                <a:spcPts val="1200"/>
-              </a:spcAft>
-              <a:buSzPct val="100000"/>
-              <a:buChar char="•"/>
+              <a:t>Check that VS Code, Git and Miniforge all work — the checklist takes two minutes</a:t>
+            </a:r>
+          </a:p>
+        </p:txBody>
+      </p:sp>
+      <p:sp>
+        <p:nvSpPr>
+          <p:cNvPr id="243" name="Circle"/>
+          <p:cNvSpPr/>
+          <p:nvPr/>
+        </p:nvSpPr>
+        <p:spPr>
+          <a:xfrm>
+            <a:off x="822960" y="2788920"/>
+            <a:ext cx="384048" cy="384048"/>
+          </a:xfrm>
+          <a:prstGeom prst="ellipse">
+            <a:avLst/>
+          </a:prstGeom>
+          <a:solidFill>
+            <a:srgbClr val="F96167"/>
+          </a:solidFill>
+          <a:ln/>
+        </p:spPr>
+        <p:txBody>
+          <a:bodyPr/>
+          <a:lstStyle/>
+          <a:p>
+            <a:endParaRPr lang="nb-NO"/>
+          </a:p>
+        </p:txBody>
+      </p:sp>
+      <p:sp>
+        <p:nvSpPr>
+          <p:cNvPr id="244" name="Text"/>
+          <p:cNvSpPr/>
+          <p:nvPr/>
+        </p:nvSpPr>
+        <p:spPr>
+          <a:xfrm>
+            <a:off x="822960" y="2788920"/>
+            <a:ext cx="384048" cy="384048"/>
+          </a:xfrm>
+          <a:prstGeom prst="rect">
+            <a:avLst/>
+          </a:prstGeom>
+          <a:noFill/>
+          <a:ln/>
+        </p:spPr>
+        <p:txBody>
+          <a:bodyPr wrap="square" rtlCol="0" anchor="ctr"/>
+          <a:lstStyle/>
+          <a:p>
+            <a:pPr marL="0" indent="0" algn="ctr">
+              <a:buNone/>
             </a:pPr>
             <a:r>
-              <a:rPr lang="en-US" sz="1600" dirty="0">
-                <a:solidFill>
-                  <a:srgbClr val="1E2761"/>
+              <a:rPr lang="en-US" sz="1500" b="1" dirty="0">
+                <a:solidFill>
+                  <a:srgbClr val="FFFFFF"/>
                 </a:solidFill>
                 <a:latin typeface="Calibri" pitchFamily="34" charset="0"/>
                 <a:ea typeface="Calibri" pitchFamily="34" charset="-122"/>
                 <a:cs typeface="Calibri" pitchFamily="34" charset="-120"/>
               </a:rPr>
-              <a:t>Install VS Code, Git and Miniforge before the workshop</a:t>
-            </a:r>
-          </a:p>
-          <a:p>
-            <a:pPr marL="342900" indent="-342900" algn="l">
-              <a:spcAft>
-                <a:spcPts val="1200"/>
-              </a:spcAft>
-              <a:buSzPct val="100000"/>
-              <a:buChar char="•"/>
+              <a:t>2</a:t>
+            </a:r>
+          </a:p>
+        </p:txBody>
+      </p:sp>
+      <p:sp>
+        <p:nvSpPr>
+          <p:cNvPr id="245" name="Text"/>
+          <p:cNvSpPr/>
+          <p:nvPr/>
+        </p:nvSpPr>
+        <p:spPr>
+          <a:xfrm>
+            <a:off x="1371600" y="2761488"/>
+            <a:ext cx="9994392" cy="457200"/>
+          </a:xfrm>
+          <a:prstGeom prst="rect">
+            <a:avLst/>
+          </a:prstGeom>
+          <a:noFill/>
+          <a:ln/>
+        </p:spPr>
+        <p:txBody>
+          <a:bodyPr wrap="square" rtlCol="0" anchor="ctr"/>
+          <a:lstStyle/>
+          <a:p>
+            <a:pPr marL="0" indent="0" algn="l">
+              <a:buNone/>
             </a:pPr>
             <a:r>
-              <a:rPr lang="en-US" sz="1600" dirty="0">
+              <a:rPr lang="en-US" dirty="0">
                 <a:solidFill>
                   <a:srgbClr val="1E2761"/>
                 </a:solidFill>
@@ -3953,31 +3834,242 @@
                 <a:ea typeface="Calibri" pitchFamily="34" charset="-122"/>
                 <a:cs typeface="Calibri" pitchFamily="34" charset="-120"/>
               </a:rPr>
-              <a:t>isabel.hovdahl@nhh.no · richard.foltyn@nhh.no</a:t>
-            </a:r>
-          </a:p>
-        </p:txBody>
-      </p:sp>
-      <p:sp>
-        <p:nvSpPr>
-          <p:cNvPr id="259" name="Box"/>
-          <p:cNvSpPr/>
-          <p:nvPr/>
-        </p:nvSpPr>
-        <p:spPr>
-          <a:xfrm>
-            <a:off x="1463040" y="5029200"/>
-            <a:ext cx="9262872" cy="1005840"/>
+              <a:t>Open Canvas, go to Modules, and find this week’s links</a:t>
+            </a:r>
+          </a:p>
+        </p:txBody>
+      </p:sp>
+      <p:sp>
+        <p:nvSpPr>
+          <p:cNvPr id="246" name="Circle"/>
+          <p:cNvSpPr/>
+          <p:nvPr/>
+        </p:nvSpPr>
+        <p:spPr>
+          <a:xfrm>
+            <a:off x="822960" y="3474720"/>
+            <a:ext cx="384048" cy="384048"/>
+          </a:xfrm>
+          <a:prstGeom prst="ellipse">
+            <a:avLst/>
+          </a:prstGeom>
+          <a:solidFill>
+            <a:srgbClr val="F96167"/>
+          </a:solidFill>
+          <a:ln/>
+        </p:spPr>
+        <p:txBody>
+          <a:bodyPr/>
+          <a:lstStyle/>
+          <a:p>
+            <a:endParaRPr lang="nb-NO"/>
+          </a:p>
+        </p:txBody>
+      </p:sp>
+      <p:sp>
+        <p:nvSpPr>
+          <p:cNvPr id="247" name="Text"/>
+          <p:cNvSpPr/>
+          <p:nvPr/>
+        </p:nvSpPr>
+        <p:spPr>
+          <a:xfrm>
+            <a:off x="822960" y="3474720"/>
+            <a:ext cx="384048" cy="384048"/>
+          </a:xfrm>
+          <a:prstGeom prst="rect">
+            <a:avLst/>
+          </a:prstGeom>
+          <a:noFill/>
+          <a:ln/>
+        </p:spPr>
+        <p:txBody>
+          <a:bodyPr wrap="square" rtlCol="0" anchor="ctr"/>
+          <a:lstStyle/>
+          <a:p>
+            <a:pPr marL="0" indent="0" algn="ctr">
+              <a:buNone/>
+            </a:pPr>
+            <a:r>
+              <a:rPr lang="en-US" sz="1500" b="1" dirty="0">
+                <a:solidFill>
+                  <a:srgbClr val="FFFFFF"/>
+                </a:solidFill>
+                <a:latin typeface="Calibri" pitchFamily="34" charset="0"/>
+                <a:ea typeface="Calibri" pitchFamily="34" charset="-122"/>
+                <a:cs typeface="Calibri" pitchFamily="34" charset="-120"/>
+              </a:rPr>
+              <a:t>3</a:t>
+            </a:r>
+          </a:p>
+        </p:txBody>
+      </p:sp>
+      <p:sp>
+        <p:nvSpPr>
+          <p:cNvPr id="248" name="Text"/>
+          <p:cNvSpPr/>
+          <p:nvPr/>
+        </p:nvSpPr>
+        <p:spPr>
+          <a:xfrm>
+            <a:off x="1371600" y="3447288"/>
+            <a:ext cx="9994392" cy="457200"/>
+          </a:xfrm>
+          <a:prstGeom prst="rect">
+            <a:avLst/>
+          </a:prstGeom>
+          <a:noFill/>
+          <a:ln/>
+        </p:spPr>
+        <p:txBody>
+          <a:bodyPr wrap="square" rtlCol="0" anchor="ctr"/>
+          <a:lstStyle/>
+          <a:p>
+            <a:pPr marL="0" indent="0" algn="l">
+              <a:buNone/>
+            </a:pPr>
+            <a:r>
+              <a:rPr lang="en-US" dirty="0">
+                <a:solidFill>
+                  <a:srgbClr val="1E2761"/>
+                </a:solidFill>
+                <a:latin typeface="Calibri" pitchFamily="34" charset="0"/>
+                <a:ea typeface="Calibri" pitchFamily="34" charset="-122"/>
+                <a:cs typeface="Calibri" pitchFamily="34" charset="-120"/>
+              </a:rPr>
+              <a:t>Read the AI guidelines — five minutes, and it will change how you work all semester</a:t>
+            </a:r>
+          </a:p>
+        </p:txBody>
+      </p:sp>
+      <p:sp>
+        <p:nvSpPr>
+          <p:cNvPr id="249" name="Circle"/>
+          <p:cNvSpPr/>
+          <p:nvPr/>
+        </p:nvSpPr>
+        <p:spPr>
+          <a:xfrm>
+            <a:off x="822960" y="4160520"/>
+            <a:ext cx="384048" cy="384048"/>
+          </a:xfrm>
+          <a:prstGeom prst="ellipse">
+            <a:avLst/>
+          </a:prstGeom>
+          <a:solidFill>
+            <a:srgbClr val="F96167"/>
+          </a:solidFill>
+          <a:ln/>
+        </p:spPr>
+        <p:txBody>
+          <a:bodyPr/>
+          <a:lstStyle/>
+          <a:p>
+            <a:endParaRPr lang="nb-NO"/>
+          </a:p>
+        </p:txBody>
+      </p:sp>
+      <p:sp>
+        <p:nvSpPr>
+          <p:cNvPr id="250" name="Text"/>
+          <p:cNvSpPr/>
+          <p:nvPr/>
+        </p:nvSpPr>
+        <p:spPr>
+          <a:xfrm>
+            <a:off x="822960" y="4160520"/>
+            <a:ext cx="384048" cy="384048"/>
+          </a:xfrm>
+          <a:prstGeom prst="rect">
+            <a:avLst/>
+          </a:prstGeom>
+          <a:noFill/>
+          <a:ln/>
+        </p:spPr>
+        <p:txBody>
+          <a:bodyPr wrap="square" rtlCol="0" anchor="ctr"/>
+          <a:lstStyle/>
+          <a:p>
+            <a:pPr marL="0" indent="0" algn="ctr">
+              <a:buNone/>
+            </a:pPr>
+            <a:r>
+              <a:rPr lang="en-US" sz="1500" b="1" dirty="0">
+                <a:solidFill>
+                  <a:srgbClr val="FFFFFF"/>
+                </a:solidFill>
+                <a:latin typeface="Calibri" pitchFamily="34" charset="0"/>
+                <a:ea typeface="Calibri" pitchFamily="34" charset="-122"/>
+                <a:cs typeface="Calibri" pitchFamily="34" charset="-120"/>
+              </a:rPr>
+              <a:t>4</a:t>
+            </a:r>
+          </a:p>
+        </p:txBody>
+      </p:sp>
+      <p:sp>
+        <p:nvSpPr>
+          <p:cNvPr id="251" name="Text"/>
+          <p:cNvSpPr/>
+          <p:nvPr/>
+        </p:nvSpPr>
+        <p:spPr>
+          <a:xfrm>
+            <a:off x="1371600" y="4133088"/>
+            <a:ext cx="9994392" cy="457200"/>
+          </a:xfrm>
+          <a:prstGeom prst="rect">
+            <a:avLst/>
+          </a:prstGeom>
+          <a:noFill/>
+          <a:ln/>
+        </p:spPr>
+        <p:txBody>
+          <a:bodyPr wrap="square" rtlCol="0" anchor="ctr"/>
+          <a:lstStyle/>
+          <a:p>
+            <a:pPr marL="0" indent="0" algn="l">
+              <a:buNone/>
+            </a:pPr>
+            <a:r>
+              <a:rPr lang="en-US" dirty="0">
+                <a:solidFill>
+                  <a:srgbClr val="1E2761"/>
+                </a:solidFill>
+                <a:latin typeface="Calibri" pitchFamily="34" charset="0"/>
+                <a:ea typeface="Calibri" pitchFamily="34" charset="-122"/>
+                <a:cs typeface="Calibri" pitchFamily="34" charset="-120"/>
+              </a:rPr>
+              <a:t>Bring your laptop to the workshop: Friday 12:15, aud. B</a:t>
+            </a:r>
+          </a:p>
+        </p:txBody>
+      </p:sp>
+      <p:sp>
+        <p:nvSpPr>
+          <p:cNvPr id="252" name="Box"/>
+          <p:cNvSpPr/>
+          <p:nvPr/>
+        </p:nvSpPr>
+        <p:spPr>
+          <a:xfrm>
+            <a:off x="822960" y="5394960"/>
+            <a:ext cx="10543032" cy="640080"/>
           </a:xfrm>
           <a:prstGeom prst="roundRect">
             <a:avLst>
-              <a:gd name="adj" fmla="val 9091"/>
+              <a:gd name="adj" fmla="val 11429"/>
             </a:avLst>
           </a:prstGeom>
           <a:solidFill>
             <a:srgbClr val="F1F4FB"/>
           </a:solidFill>
-          <a:ln/>
+          <a:ln w="15875">
+            <a:solidFill>
+              <a:srgbClr val="F96167"/>
+            </a:solidFill>
+            <a:prstDash val="solid"/>
+          </a:ln>
         </p:spPr>
         <p:txBody>
           <a:bodyPr/>
@@ -3989,14 +4081,14 @@
       </p:sp>
       <p:sp>
         <p:nvSpPr>
-          <p:cNvPr id="260" name="Text"/>
-          <p:cNvSpPr/>
-          <p:nvPr/>
-        </p:nvSpPr>
-        <p:spPr>
-          <a:xfrm>
-            <a:off x="1645920" y="5029200"/>
-            <a:ext cx="8897112" cy="1005840"/>
+          <p:cNvPr id="253" name="Text"/>
+          <p:cNvSpPr/>
+          <p:nvPr/>
+        </p:nvSpPr>
+        <p:spPr>
+          <a:xfrm>
+            <a:off x="1051560" y="5394960"/>
+            <a:ext cx="10085832" cy="640080"/>
           </a:xfrm>
           <a:prstGeom prst="rect">
             <a:avLst/>
@@ -4008,11 +4100,11 @@
           <a:bodyPr wrap="square" rtlCol="0" anchor="ctr"/>
           <a:lstStyle/>
           <a:p>
-            <a:pPr marL="0" indent="0" algn="ctr">
+            <a:pPr marL="0" indent="0" algn="l">
               <a:buNone/>
             </a:pPr>
             <a:r>
-              <a:rPr lang="en-US" sz="1500" b="1" dirty="0">
+              <a:rPr lang="en-US" sz="1600" b="1" i="1" dirty="0">
                 <a:solidFill>
                   <a:srgbClr val="1E2761"/>
                 </a:solidFill>
@@ -4020,10 +4112,10 @@
                 <a:ea typeface="Calibri" pitchFamily="34" charset="-122"/>
                 <a:cs typeface="Calibri" pitchFamily="34" charset="-120"/>
               </a:rPr>
-              <a:t>Friday: Getting Started with VS Code</a:t>
-            </a:r>
-            <a:r>
-              <a:rPr lang="en-US" sz="1500" dirty="0">
+              <a:t>Nothing to prepare beyond this</a:t>
+            </a:r>
+            <a:r>
+              <a:rPr lang="en-US" sz="1600" i="1" dirty="0">
                 <a:solidFill>
                   <a:srgbClr val="1E2761"/>
                 </a:solidFill>
@@ -4031,7 +4123,45 @@
                 <a:ea typeface="Calibri" pitchFamily="34" charset="-122"/>
                 <a:cs typeface="Calibri" pitchFamily="34" charset="-120"/>
               </a:rPr>
-              <a:t> — your first Python script and your first notebook.</a:t>
+              <a:t>. Turn up on Friday and we start writing code.</a:t>
+            </a:r>
+          </a:p>
+        </p:txBody>
+      </p:sp>
+      <p:sp>
+        <p:nvSpPr>
+          <p:cNvPr id="254" name="SlideNumber"/>
+          <p:cNvSpPr/>
+          <p:nvPr/>
+        </p:nvSpPr>
+        <p:spPr>
+          <a:xfrm>
+            <a:off x="11274552" y="6492240"/>
+            <a:ext cx="457200" cy="274320"/>
+          </a:xfrm>
+          <a:prstGeom prst="rect">
+            <a:avLst/>
+          </a:prstGeom>
+          <a:noFill/>
+          <a:ln/>
+        </p:spPr>
+        <p:txBody>
+          <a:bodyPr wrap="square" rtlCol="0" anchor="ctr"/>
+          <a:lstStyle/>
+          <a:p>
+            <a:pPr marL="0" indent="0" algn="r">
+              <a:buNone/>
+            </a:pPr>
+            <a:r>
+              <a:rPr lang="en-US" sz="900" dirty="0">
+                <a:solidFill>
+                  <a:srgbClr val="5B6472"/>
+                </a:solidFill>
+                <a:latin typeface="Calibri" pitchFamily="34" charset="0"/>
+                <a:ea typeface="Calibri" pitchFamily="34" charset="-122"/>
+                <a:cs typeface="Calibri" pitchFamily="34" charset="-120"/>
+              </a:rPr>
+              <a:t>13</a:t>
             </a:r>
           </a:p>
         </p:txBody>
@@ -4071,81 +4201,14 @@
       </p:grpSpPr>
       <p:sp>
         <p:nvSpPr>
-          <p:cNvPr id="226" name="Box"/>
-          <p:cNvSpPr/>
-          <p:nvPr/>
-        </p:nvSpPr>
-        <p:spPr>
-          <a:xfrm>
-            <a:off x="457200" y="411480"/>
-            <a:ext cx="2011680" cy="329184"/>
-          </a:xfrm>
-          <a:prstGeom prst="roundRect">
-            <a:avLst>
-              <a:gd name="adj" fmla="val 50000"/>
-            </a:avLst>
-          </a:prstGeom>
-          <a:solidFill>
-            <a:srgbClr val="1E2761"/>
-          </a:solidFill>
-          <a:ln/>
-        </p:spPr>
-        <p:txBody>
-          <a:bodyPr/>
-          <a:lstStyle/>
-          <a:p>
-            <a:endParaRPr lang="nb-NO"/>
-          </a:p>
-        </p:txBody>
-      </p:sp>
-      <p:sp>
-        <p:nvSpPr>
-          <p:cNvPr id="227" name="Text"/>
-          <p:cNvSpPr/>
-          <p:nvPr/>
-        </p:nvSpPr>
-        <p:spPr>
-          <a:xfrm>
-            <a:off x="457200" y="411480"/>
-            <a:ext cx="2011680" cy="329184"/>
-          </a:xfrm>
-          <a:prstGeom prst="rect">
-            <a:avLst/>
-          </a:prstGeom>
-          <a:noFill/>
-          <a:ln/>
-        </p:spPr>
-        <p:txBody>
-          <a:bodyPr wrap="square" rtlCol="0" anchor="ctr"/>
-          <a:lstStyle/>
-          <a:p>
-            <a:pPr marL="0" indent="0" algn="ctr">
-              <a:buNone/>
-            </a:pPr>
-            <a:r>
-              <a:rPr lang="en-US" sz="1100" b="1" kern="0" spc="100" dirty="0">
-                <a:solidFill>
-                  <a:srgbClr val="FFFFFF"/>
-                </a:solidFill>
-                <a:latin typeface="Calibri" pitchFamily="34" charset="0"/>
-                <a:ea typeface="Calibri" pitchFamily="34" charset="-122"/>
-                <a:cs typeface="Calibri" pitchFamily="34" charset="-120"/>
-              </a:rPr>
-              <a:t>CONCEPT</a:t>
-            </a:r>
-          </a:p>
-        </p:txBody>
-      </p:sp>
-      <p:sp>
-        <p:nvSpPr>
-          <p:cNvPr id="228" name="Circle"/>
-          <p:cNvSpPr/>
-          <p:nvPr/>
-        </p:nvSpPr>
-        <p:spPr>
-          <a:xfrm>
-            <a:off x="10771632" y="384048"/>
-            <a:ext cx="822960" cy="822960"/>
+          <p:cNvPr id="255" name="Circle"/>
+          <p:cNvSpPr/>
+          <p:nvPr/>
+        </p:nvSpPr>
+        <p:spPr>
+          <a:xfrm>
+            <a:off x="5637276" y="1051560"/>
+            <a:ext cx="914400" cy="914400"/>
           </a:xfrm>
           <a:prstGeom prst="ellipse">
             <a:avLst/>
@@ -4165,7 +4228,7 @@
       </p:sp>
       <p:pic>
         <p:nvPicPr>
-          <p:cNvPr id="229" name="Icon" descr="icons/monitor.png"/>
+          <p:cNvPr id="256" name="Icon" descr="icons/check_circle.png"/>
           <p:cNvPicPr>
             <a:picLocks noChangeAspect="1"/>
           </p:cNvPicPr>
@@ -4179,8 +4242,8 @@
         </p:blipFill>
         <p:spPr>
           <a:xfrm>
-            <a:off x="10862158" y="474574"/>
-            <a:ext cx="641909" cy="641909"/>
+            <a:off x="5774436" y="1190460"/>
+            <a:ext cx="640080" cy="640080"/>
           </a:xfrm>
           <a:prstGeom prst="rect">
             <a:avLst/>
@@ -4189,14 +4252,14 @@
       </p:pic>
       <p:sp>
         <p:nvSpPr>
-          <p:cNvPr id="230" name="Text"/>
-          <p:cNvSpPr/>
-          <p:nvPr/>
-        </p:nvSpPr>
-        <p:spPr>
-          <a:xfrm>
-            <a:off x="457200" y="896112"/>
-            <a:ext cx="11274552" cy="822960"/>
+          <p:cNvPr id="257" name="Text"/>
+          <p:cNvSpPr/>
+          <p:nvPr/>
+        </p:nvSpPr>
+        <p:spPr>
+          <a:xfrm>
+            <a:off x="731520" y="1921400"/>
+            <a:ext cx="10725912" cy="640080"/>
           </a:xfrm>
           <a:prstGeom prst="rect">
             <a:avLst/>
@@ -4205,10 +4268,10 @@
           <a:ln/>
         </p:spPr>
         <p:txBody>
-          <a:bodyPr wrap="square" rtlCol="0" anchor="t"/>
-          <a:lstStyle/>
-          <a:p>
-            <a:pPr marL="0" indent="0" algn="l">
+          <a:bodyPr wrap="square" rtlCol="0" anchor="ctr"/>
+          <a:lstStyle/>
+          <a:p>
+            <a:pPr marL="0" indent="0" algn="ctr">
               <a:buNone/>
             </a:pPr>
             <a:r>
@@ -4220,21 +4283,21 @@
                 <a:ea typeface="Cambria" pitchFamily="34" charset="-122"/>
                 <a:cs typeface="Cambria" pitchFamily="34" charset="-120"/>
               </a:rPr>
-              <a:t>Meet TECHi</a:t>
-            </a:r>
-          </a:p>
-        </p:txBody>
-      </p:sp>
-      <p:sp>
-        <p:nvSpPr>
-          <p:cNvPr id="231" name="Bullets"/>
-          <p:cNvSpPr/>
-          <p:nvPr/>
-        </p:nvSpPr>
-        <p:spPr>
-          <a:xfrm>
-            <a:off x="822960" y="1920240"/>
-            <a:ext cx="10543032" cy="3200400"/>
+              <a:t>See You on Friday</a:t>
+            </a:r>
+          </a:p>
+        </p:txBody>
+      </p:sp>
+      <p:sp>
+        <p:nvSpPr>
+          <p:cNvPr id="258" name="Bullets"/>
+          <p:cNvSpPr/>
+          <p:nvPr/>
+        </p:nvSpPr>
+        <p:spPr>
+          <a:xfrm>
+            <a:off x="2194560" y="2744360"/>
+            <a:ext cx="7799832" cy="2011680"/>
           </a:xfrm>
           <a:prstGeom prst="rect">
             <a:avLst/>
@@ -4254,7 +4317,7 @@
               <a:buChar char="•"/>
             </a:pPr>
             <a:r>
-              <a:rPr lang="en-US" dirty="0">
+              <a:rPr lang="en-US" sz="1600" dirty="0">
                 <a:solidFill>
                   <a:srgbClr val="1E2761"/>
                 </a:solidFill>
@@ -4262,7 +4325,7 @@
                 <a:ea typeface="Calibri" pitchFamily="34" charset="-122"/>
                 <a:cs typeface="Calibri" pitchFamily="34" charset="-120"/>
               </a:rPr>
-              <a:t>Built for this course — it knows the lecture material, the exercises, and where we are in the syllabus</a:t>
+              <a:t>Lectures Wednesdays 08:15 · Workshops Fridays 12:15 · aud. B</a:t>
             </a:r>
           </a:p>
           <a:p>
@@ -4274,7 +4337,7 @@
               <a:buChar char="•"/>
             </a:pPr>
             <a:r>
-              <a:rPr lang="en-US" dirty="0">
+              <a:rPr lang="en-US" sz="1600" dirty="0">
                 <a:solidFill>
                   <a:srgbClr val="1E2761"/>
                 </a:solidFill>
@@ -4282,7 +4345,7 @@
                 <a:ea typeface="Calibri" pitchFamily="34" charset="-122"/>
                 <a:cs typeface="Calibri" pitchFamily="34" charset="-120"/>
               </a:rPr>
-              <a:t>Privacy-friendly — your conversations are not sent to a commercial AI provider</a:t>
+              <a:t>All material on GitHub, linked from Canvas — Modules</a:t>
             </a:r>
           </a:p>
           <a:p>
@@ -4294,7 +4357,7 @@
               <a:buChar char="•"/>
             </a:pPr>
             <a:r>
-              <a:rPr lang="en-US" dirty="0">
+              <a:rPr lang="en-US" sz="1600" dirty="0">
                 <a:solidFill>
                   <a:srgbClr val="1E2761"/>
                 </a:solidFill>
@@ -4302,7 +4365,7 @@
                 <a:ea typeface="Calibri" pitchFamily="34" charset="-122"/>
                 <a:cs typeface="Calibri" pitchFamily="34" charset="-120"/>
               </a:rPr>
-              <a:t>Socratic by design — it will not hand you the code. It asks questions and gives hints, so the thinking stays yours</a:t>
+              <a:t>Install VS Code, Git and Miniforge before the workshop</a:t>
             </a:r>
           </a:p>
           <a:p>
@@ -4314,7 +4377,7 @@
               <a:buChar char="•"/>
             </a:pPr>
             <a:r>
-              <a:rPr lang="en-US" dirty="0">
+              <a:rPr lang="en-US" sz="1600" dirty="0">
                 <a:solidFill>
                   <a:srgbClr val="1E2761"/>
                 </a:solidFill>
@@ -4322,19 +4385,66 @@
                 <a:ea typeface="Calibri" pitchFamily="34" charset="-122"/>
                 <a:cs typeface="Calibri" pitchFamily="34" charset="-120"/>
               </a:rPr>
-              <a:t>Find it on Canvas under Start here — nothing to install, no account to create</a:t>
-            </a:r>
-          </a:p>
-          <a:p>
-            <a:pPr marL="342900" indent="-342900" algn="l">
-              <a:spcAft>
-                <a:spcPts val="1200"/>
-              </a:spcAft>
-              <a:buSzPct val="100000"/>
-              <a:buChar char="•"/>
+              <a:t>isabel.hovdahl@nhh.no · richard.foltyn@nhh.no</a:t>
+            </a:r>
+          </a:p>
+        </p:txBody>
+      </p:sp>
+      <p:sp>
+        <p:nvSpPr>
+          <p:cNvPr id="259" name="Box"/>
+          <p:cNvSpPr/>
+          <p:nvPr/>
+        </p:nvSpPr>
+        <p:spPr>
+          <a:xfrm>
+            <a:off x="1463040" y="5029200"/>
+            <a:ext cx="9262872" cy="1005840"/>
+          </a:xfrm>
+          <a:prstGeom prst="roundRect">
+            <a:avLst>
+              <a:gd name="adj" fmla="val 9091"/>
+            </a:avLst>
+          </a:prstGeom>
+          <a:solidFill>
+            <a:srgbClr val="F1F4FB"/>
+          </a:solidFill>
+          <a:ln/>
+        </p:spPr>
+        <p:txBody>
+          <a:bodyPr/>
+          <a:lstStyle/>
+          <a:p>
+            <a:endParaRPr lang="nb-NO"/>
+          </a:p>
+        </p:txBody>
+      </p:sp>
+      <p:sp>
+        <p:nvSpPr>
+          <p:cNvPr id="260" name="Text"/>
+          <p:cNvSpPr/>
+          <p:nvPr/>
+        </p:nvSpPr>
+        <p:spPr>
+          <a:xfrm>
+            <a:off x="1645920" y="5029200"/>
+            <a:ext cx="8897112" cy="1005840"/>
+          </a:xfrm>
+          <a:prstGeom prst="rect">
+            <a:avLst/>
+          </a:prstGeom>
+          <a:noFill/>
+          <a:ln/>
+        </p:spPr>
+        <p:txBody>
+          <a:bodyPr wrap="square" rtlCol="0" anchor="ctr"/>
+          <a:lstStyle/>
+          <a:p>
+            <a:pPr marL="0" indent="0" algn="ctr">
+              <a:buNone/>
             </a:pPr>
             <a:r>
-              <a:rPr lang="en-US" dirty="0">
+              <a:rPr lang="en-US" sz="1500" b="1" dirty="0">
                 <a:solidFill>
                   <a:srgbClr val="1E2761"/>
                 </a:solidFill>
@@ -4342,71 +4452,10 @@
                 <a:ea typeface="Calibri" pitchFamily="34" charset="-122"/>
                 <a:cs typeface="Calibri" pitchFamily="34" charset="-120"/>
               </a:rPr>
-              <a:t>You may still use other AI tools. The same guidelines apply, and so does declaring your use</a:t>
-            </a:r>
-          </a:p>
-        </p:txBody>
-      </p:sp>
-      <p:sp>
-        <p:nvSpPr>
-          <p:cNvPr id="232" name="Box"/>
-          <p:cNvSpPr/>
-          <p:nvPr/>
-        </p:nvSpPr>
-        <p:spPr>
-          <a:xfrm>
-            <a:off x="822960" y="5394960"/>
-            <a:ext cx="10543032" cy="640080"/>
-          </a:xfrm>
-          <a:prstGeom prst="roundRect">
-            <a:avLst>
-              <a:gd name="adj" fmla="val 11429"/>
-            </a:avLst>
-          </a:prstGeom>
-          <a:solidFill>
-            <a:srgbClr val="F1F4FB"/>
-          </a:solidFill>
-          <a:ln w="15875">
-            <a:solidFill>
-              <a:srgbClr val="F96167"/>
-            </a:solidFill>
-            <a:prstDash val="solid"/>
-          </a:ln>
-        </p:spPr>
-        <p:txBody>
-          <a:bodyPr/>
-          <a:lstStyle/>
-          <a:p>
-            <a:endParaRPr lang="nb-NO"/>
-          </a:p>
-        </p:txBody>
-      </p:sp>
-      <p:sp>
-        <p:nvSpPr>
-          <p:cNvPr id="233" name="Text"/>
-          <p:cNvSpPr/>
-          <p:nvPr/>
-        </p:nvSpPr>
-        <p:spPr>
-          <a:xfrm>
-            <a:off x="1051560" y="5394960"/>
-            <a:ext cx="10085832" cy="640080"/>
-          </a:xfrm>
-          <a:prstGeom prst="rect">
-            <a:avLst/>
-          </a:prstGeom>
-          <a:noFill/>
-          <a:ln/>
-        </p:spPr>
-        <p:txBody>
-          <a:bodyPr wrap="square" rtlCol="0" anchor="ctr"/>
-          <a:lstStyle/>
-          <a:p>
-            <a:pPr marL="0" indent="0" algn="l">
-              <a:buNone/>
-            </a:pPr>
-            <a:r>
-              <a:rPr lang="en-US" sz="1600" b="1" i="1" dirty="0">
+              <a:t>Friday: Getting Started with VS Code</a:t>
+            </a:r>
+            <a:r>
+              <a:rPr lang="en-US" sz="1500" dirty="0">
                 <a:solidFill>
                   <a:srgbClr val="1E2761"/>
                 </a:solidFill>
@@ -4414,56 +4463,7 @@
                 <a:ea typeface="Calibri" pitchFamily="34" charset="-122"/>
                 <a:cs typeface="Calibri" pitchFamily="34" charset="-120"/>
               </a:rPr>
-              <a:t>It will not give you the answer, and that is the point</a:t>
-            </a:r>
-            <a:r>
-              <a:rPr lang="en-US" sz="1600" i="1" dirty="0">
-                <a:solidFill>
-                  <a:srgbClr val="1E2761"/>
-                </a:solidFill>
-                <a:latin typeface="Calibri" pitchFamily="34" charset="0"/>
-                <a:ea typeface="Calibri" pitchFamily="34" charset="-122"/>
-                <a:cs typeface="Calibri" pitchFamily="34" charset="-120"/>
-              </a:rPr>
-              <a:t>. Try it on something you are genuinely stuck on — that is when it is most useful.</a:t>
-            </a:r>
-          </a:p>
-        </p:txBody>
-      </p:sp>
-      <p:sp>
-        <p:nvSpPr>
-          <p:cNvPr id="234" name="SlideNumber"/>
-          <p:cNvSpPr/>
-          <p:nvPr/>
-        </p:nvSpPr>
-        <p:spPr>
-          <a:xfrm>
-            <a:off x="11274552" y="6492240"/>
-            <a:ext cx="457200" cy="274320"/>
-          </a:xfrm>
-          <a:prstGeom prst="rect">
-            <a:avLst/>
-          </a:prstGeom>
-          <a:noFill/>
-          <a:ln/>
-        </p:spPr>
-        <p:txBody>
-          <a:bodyPr wrap="square" rtlCol="0" anchor="ctr"/>
-          <a:lstStyle/>
-          <a:p>
-            <a:pPr marL="0" indent="0" algn="r">
-              <a:buNone/>
-            </a:pPr>
-            <a:r>
-              <a:rPr lang="en-US" sz="900" dirty="0">
-                <a:solidFill>
-                  <a:srgbClr val="5B6472"/>
-                </a:solidFill>
-                <a:latin typeface="Calibri" pitchFamily="34" charset="0"/>
-                <a:ea typeface="Calibri" pitchFamily="34" charset="-122"/>
-                <a:cs typeface="Calibri" pitchFamily="34" charset="-120"/>
-              </a:rPr>
-              <a:t>12</a:t>
+              <a:t> — your first Python script and your first notebook.</a:t>
             </a:r>
           </a:p>
         </p:txBody>
@@ -12071,7 +12071,7 @@
                 <a:ea typeface="Calibri" pitchFamily="34" charset="-122"/>
                 <a:cs typeface="Calibri" pitchFamily="34" charset="-120"/>
               </a:rPr>
-              <a:t>Already have Anaconda or Miniconda? You are fine — no need to change anything.</a:t>
+              <a:t>Already have Python installed some other way? Install Miniforge anyway — the course assumes it</a:t>
             </a:r>
           </a:p>
           <a:p>

</xml_diff>

<commit_message>
Add home exam dates
</commit_message>
<xml_diff>
--- a/lectures/00-introduction.pptx
+++ b/lectures/00-introduction.pptx
@@ -126,7 +126,7 @@
 <file path=ppt/revisionInfo.xml><?xml version="1.0" encoding="utf-8"?>
 <p1510:revInfo xmlns:a="http://schemas.openxmlformats.org/drawingml/2006/main" xmlns:r="http://schemas.openxmlformats.org/officeDocument/2006/relationships" xmlns:p1510="http://schemas.microsoft.com/office/powerpoint/2015/10/main">
   <p1510:revLst>
-    <p1510:client id="{6E0B44DB-6B5F-4191-BBE5-E466B355467C}" v="1" dt="2026-08-09T11:12:19.470"/>
+    <p1510:client id="{6E0B44DB-6B5F-4191-BBE5-E466B355467C}" v="1" dt="2026-08-18T08:45:24.723"/>
   </p1510:revLst>
 </p1510:revInfo>
 </file>
@@ -136,7 +136,7 @@
   <pc:docChgLst>
     <pc:chgData name="Isabel Montero Hovdahl" userId="e6c00a4d-4ab5-475c-996d-11be2680c122" providerId="ADAL" clId="{492A1D5D-B8BD-4473-8F28-59B786D7141F}"/>
     <pc:docChg chg="undo custSel modSld">
-      <pc:chgData name="Isabel Montero Hovdahl" userId="e6c00a4d-4ab5-475c-996d-11be2680c122" providerId="ADAL" clId="{492A1D5D-B8BD-4473-8F28-59B786D7141F}" dt="2026-08-10T07:50:14.778" v="685" actId="6549"/>
+      <pc:chgData name="Isabel Montero Hovdahl" userId="e6c00a4d-4ab5-475c-996d-11be2680c122" providerId="ADAL" clId="{492A1D5D-B8BD-4473-8F28-59B786D7141F}" dt="2026-08-18T08:45:29.881" v="719" actId="20577"/>
       <pc:docMkLst>
         <pc:docMk/>
       </pc:docMkLst>
@@ -156,13 +156,13 @@
         </pc:spChg>
       </pc:sldChg>
       <pc:sldChg chg="modSp mod">
-        <pc:chgData name="Isabel Montero Hovdahl" userId="e6c00a4d-4ab5-475c-996d-11be2680c122" providerId="ADAL" clId="{492A1D5D-B8BD-4473-8F28-59B786D7141F}" dt="2026-08-09T11:30:44.708" v="466" actId="404"/>
+        <pc:chgData name="Isabel Montero Hovdahl" userId="e6c00a4d-4ab5-475c-996d-11be2680c122" providerId="ADAL" clId="{492A1D5D-B8BD-4473-8F28-59B786D7141F}" dt="2026-08-18T08:44:36.159" v="687" actId="20577"/>
         <pc:sldMkLst>
           <pc:docMk/>
           <pc:sldMk cId="0" sldId="257"/>
         </pc:sldMkLst>
         <pc:spChg chg="mod">
-          <ac:chgData name="Isabel Montero Hovdahl" userId="e6c00a4d-4ab5-475c-996d-11be2680c122" providerId="ADAL" clId="{492A1D5D-B8BD-4473-8F28-59B786D7141F}" dt="2026-08-09T11:29:36.115" v="454" actId="403"/>
+          <ac:chgData name="Isabel Montero Hovdahl" userId="e6c00a4d-4ab5-475c-996d-11be2680c122" providerId="ADAL" clId="{492A1D5D-B8BD-4473-8F28-59B786D7141F}" dt="2026-08-18T08:44:36.159" v="687" actId="20577"/>
           <ac:spMkLst>
             <pc:docMk/>
             <pc:sldMk cId="0" sldId="257"/>
@@ -179,13 +179,13 @@
         </pc:spChg>
       </pc:sldChg>
       <pc:sldChg chg="modSp mod">
-        <pc:chgData name="Isabel Montero Hovdahl" userId="e6c00a4d-4ab5-475c-996d-11be2680c122" providerId="ADAL" clId="{492A1D5D-B8BD-4473-8F28-59B786D7141F}" dt="2026-08-09T11:30:49.423" v="467" actId="404"/>
+        <pc:chgData name="Isabel Montero Hovdahl" userId="e6c00a4d-4ab5-475c-996d-11be2680c122" providerId="ADAL" clId="{492A1D5D-B8BD-4473-8F28-59B786D7141F}" dt="2026-08-18T08:44:44.975" v="689" actId="20577"/>
         <pc:sldMkLst>
           <pc:docMk/>
           <pc:sldMk cId="0" sldId="258"/>
         </pc:sldMkLst>
         <pc:spChg chg="mod">
-          <ac:chgData name="Isabel Montero Hovdahl" userId="e6c00a4d-4ab5-475c-996d-11be2680c122" providerId="ADAL" clId="{492A1D5D-B8BD-4473-8F28-59B786D7141F}" dt="2026-08-09T11:29:59.125" v="458" actId="403"/>
+          <ac:chgData name="Isabel Montero Hovdahl" userId="e6c00a4d-4ab5-475c-996d-11be2680c122" providerId="ADAL" clId="{492A1D5D-B8BD-4473-8F28-59B786D7141F}" dt="2026-08-18T08:44:41.713" v="688" actId="20577"/>
           <ac:spMkLst>
             <pc:docMk/>
             <pc:sldMk cId="0" sldId="258"/>
@@ -193,7 +193,7 @@
           </ac:spMkLst>
         </pc:spChg>
         <pc:spChg chg="mod">
-          <ac:chgData name="Isabel Montero Hovdahl" userId="e6c00a4d-4ab5-475c-996d-11be2680c122" providerId="ADAL" clId="{492A1D5D-B8BD-4473-8F28-59B786D7141F}" dt="2026-08-09T11:29:56.672" v="457" actId="403"/>
+          <ac:chgData name="Isabel Montero Hovdahl" userId="e6c00a4d-4ab5-475c-996d-11be2680c122" providerId="ADAL" clId="{492A1D5D-B8BD-4473-8F28-59B786D7141F}" dt="2026-08-18T08:44:44.975" v="689" actId="20577"/>
           <ac:spMkLst>
             <pc:docMk/>
             <pc:sldMk cId="0" sldId="258"/>
@@ -264,13 +264,13 @@
         </pc:graphicFrameChg>
       </pc:sldChg>
       <pc:sldChg chg="modSp mod">
-        <pc:chgData name="Isabel Montero Hovdahl" userId="e6c00a4d-4ab5-475c-996d-11be2680c122" providerId="ADAL" clId="{492A1D5D-B8BD-4473-8F28-59B786D7141F}" dt="2026-08-09T11:31:17.599" v="474" actId="403"/>
+        <pc:chgData name="Isabel Montero Hovdahl" userId="e6c00a4d-4ab5-475c-996d-11be2680c122" providerId="ADAL" clId="{492A1D5D-B8BD-4473-8F28-59B786D7141F}" dt="2026-08-18T08:44:56.342" v="691" actId="20577"/>
         <pc:sldMkLst>
           <pc:docMk/>
           <pc:sldMk cId="0" sldId="261"/>
         </pc:sldMkLst>
         <pc:spChg chg="mod">
-          <ac:chgData name="Isabel Montero Hovdahl" userId="e6c00a4d-4ab5-475c-996d-11be2680c122" providerId="ADAL" clId="{492A1D5D-B8BD-4473-8F28-59B786D7141F}" dt="2026-08-09T11:31:10.172" v="471" actId="403"/>
+          <ac:chgData name="Isabel Montero Hovdahl" userId="e6c00a4d-4ab5-475c-996d-11be2680c122" providerId="ADAL" clId="{492A1D5D-B8BD-4473-8F28-59B786D7141F}" dt="2026-08-18T08:44:54.432" v="690" actId="20577"/>
           <ac:spMkLst>
             <pc:docMk/>
             <pc:sldMk cId="0" sldId="261"/>
@@ -278,7 +278,7 @@
           </ac:spMkLst>
         </pc:spChg>
         <pc:spChg chg="mod">
-          <ac:chgData name="Isabel Montero Hovdahl" userId="e6c00a4d-4ab5-475c-996d-11be2680c122" providerId="ADAL" clId="{492A1D5D-B8BD-4473-8F28-59B786D7141F}" dt="2026-08-09T11:31:12.762" v="472" actId="403"/>
+          <ac:chgData name="Isabel Montero Hovdahl" userId="e6c00a4d-4ab5-475c-996d-11be2680c122" providerId="ADAL" clId="{492A1D5D-B8BD-4473-8F28-59B786D7141F}" dt="2026-08-18T08:44:56.342" v="691" actId="20577"/>
           <ac:spMkLst>
             <pc:docMk/>
             <pc:sldMk cId="0" sldId="261"/>
@@ -387,7 +387,7 @@
         </pc:spChg>
       </pc:sldChg>
       <pc:sldChg chg="modSp mod">
-        <pc:chgData name="Isabel Montero Hovdahl" userId="e6c00a4d-4ab5-475c-996d-11be2680c122" providerId="ADAL" clId="{492A1D5D-B8BD-4473-8F28-59B786D7141F}" dt="2026-08-10T07:43:58.242" v="513" actId="20577"/>
+        <pc:chgData name="Isabel Montero Hovdahl" userId="e6c00a4d-4ab5-475c-996d-11be2680c122" providerId="ADAL" clId="{492A1D5D-B8BD-4473-8F28-59B786D7141F}" dt="2026-08-18T08:45:29.881" v="719" actId="20577"/>
         <pc:sldMkLst>
           <pc:docMk/>
           <pc:sldMk cId="0" sldId="266"/>
@@ -400,8 +400,8 @@
             <ac:spMk id="224" creationId="{00000000-0000-0000-0000-000000000000}"/>
           </ac:spMkLst>
         </pc:spChg>
-        <pc:graphicFrameChg chg="modGraphic">
-          <ac:chgData name="Isabel Montero Hovdahl" userId="e6c00a4d-4ab5-475c-996d-11be2680c122" providerId="ADAL" clId="{492A1D5D-B8BD-4473-8F28-59B786D7141F}" dt="2026-08-10T07:43:58.242" v="513" actId="20577"/>
+        <pc:graphicFrameChg chg="mod modGraphic">
+          <ac:chgData name="Isabel Montero Hovdahl" userId="e6c00a4d-4ab5-475c-996d-11be2680c122" providerId="ADAL" clId="{492A1D5D-B8BD-4473-8F28-59B786D7141F}" dt="2026-08-18T08:45:29.881" v="719" actId="20577"/>
           <ac:graphicFrameMkLst>
             <pc:docMk/>
             <pc:sldMk cId="0" sldId="266"/>
@@ -1600,7 +1600,7 @@
           <p:nvPr>
             <p:extLst>
               <p:ext uri="{D42A27DB-BD31-4B8C-83A1-F6EECF244321}">
-                <p14:modId xmlns:p14="http://schemas.microsoft.com/office/powerpoint/2010/main" val="2144282742"/>
+                <p14:modId xmlns:p14="http://schemas.microsoft.com/office/powerpoint/2010/main" val="1519663536"/>
               </p:ext>
             </p:extLst>
           </p:nvPr>
@@ -2344,7 +2344,7 @@
                           <a:ea typeface="Calibri" pitchFamily="34" charset="-122"/>
                           <a:cs typeface="Calibri" pitchFamily="34" charset="-120"/>
                         </a:rPr>
-                        <a:t>Announced on Canvas</a:t>
+                        <a:t>23–25 November</a:t>
                       </a:r>
                     </a:p>
                   </a:txBody>
@@ -4694,7 +4694,7 @@
                 <a:ea typeface="Calibri" pitchFamily="34" charset="-122"/>
                 <a:cs typeface="Calibri" pitchFamily="34" charset="-120"/>
               </a:rPr>
-              <a:t>Two halves: programming fundamentals with Isabel (weeks 34– 39), then working with data with Richard (weeks 40– 45)</a:t>
+              <a:t>Two halves: programming fundamentals with Isabel (weeks 34–39), then working with data with Richard (weeks 40–45)</a:t>
             </a:r>
           </a:p>
           <a:p>
@@ -5167,7 +5167,7 @@
                 <a:ea typeface="Calibri" pitchFamily="34" charset="-122"/>
                 <a:cs typeface="Calibri" pitchFamily="34" charset="-120"/>
               </a:rPr>
-              <a:t>Weeks 34– 39 — Isabel Hovdahl: Python basics, decisions, loops, functions, packages</a:t>
+              <a:t>Weeks 34–39 — Isabel Hovdahl: Python basics, decisions, loops, functions, packages</a:t>
             </a:r>
           </a:p>
         </p:txBody>
@@ -5270,7 +5270,7 @@
                 <a:ea typeface="Calibri" pitchFamily="34" charset="-122"/>
                 <a:cs typeface="Calibri" pitchFamily="34" charset="-120"/>
               </a:rPr>
-              <a:t>Weeks 40– 45 — Richard Foltyn: GitHub, NumPy, pandas, plotting, data wrangling, AI</a:t>
+              <a:t>Weeks 40–45 — Richard Foltyn: GitHub, NumPy, pandas, plotting, data wrangling, AI</a:t>
             </a:r>
           </a:p>
         </p:txBody>
@@ -7644,7 +7644,7 @@
                 <a:ea typeface="Calibri" pitchFamily="34" charset="-122"/>
                 <a:cs typeface="Calibri" pitchFamily="34" charset="-120"/>
               </a:rPr>
-              <a:t>Lecture — Wednesdays 08:15– 10:00, aud. B: new ideas, worked examples, live coding</a:t>
+              <a:t>Lecture — Wednesdays 08:15–10:00, aud. B: new ideas, worked examples, live coding</a:t>
             </a:r>
           </a:p>
         </p:txBody>
@@ -7747,7 +7747,7 @@
                 <a:ea typeface="Calibri" pitchFamily="34" charset="-122"/>
                 <a:cs typeface="Calibri" pitchFamily="34" charset="-120"/>
               </a:rPr>
-              <a:t>Workshop — Fridays 12:15– 14:00, aud. B: you write the code, we help when you get stuck</a:t>
+              <a:t>Workshop — Fridays 12:15–14:00, aud. B: you write the code, we help when you get stuck</a:t>
             </a:r>
           </a:p>
         </p:txBody>

</xml_diff>